<commit_message>
Update README, design, setup guide and slides for the 6-task implementation
Co-Authored-By: Claude Opus 5.5 <noreply@anthropic.com>
Claude-Session: https://claude.ai/code/session_0116PzoLqmEDkoGgTUxBXqhy
</commit_message>
<xml_diff>
--- a/docs/presentation.pptx
+++ b/docs/presentation.pptx
@@ -18,9 +18,10 @@
     <p:sldId id="266" r:id="rId12"/>
     <p:sldId id="267" r:id="rId13"/>
     <p:sldId id="268" r:id="rId14"/>
+    <p:sldId id="269" r:id="rId15"/>
   </p:sldIdLst>
   <p:notesMasterIdLst>
-    <p:notesMasterId r:id="rId15"/>
+    <p:notesMasterId r:id="rId16"/>
   </p:notesMasterIdLst>
   <p:sldSz cx="9144000" cy="5143500"/>
   <p:notesSz cx="5143500" cy="9144000"/>
@@ -1198,6 +1199,94 @@
             <a:fld id="{F7021451-1387-4CA6-816F-3879F97B5CBC}" type="slidenum">
               <a:rPr lang="en-US"/>
               <a:t>13</a:t>
+            </a:fld>
+            <a:endParaRPr lang="en-US"/>
+          </a:p>
+        </p:txBody>
+      </p:sp>
+    </p:spTree>
+    <p:extLst>
+      <p:ext uri="{BB962C8B-B14F-4D97-AF65-F5344CB8AC3E}">
+        <p14:creationId xmlns:p14="http://schemas.microsoft.com/office/powerpoint/2010/main" val="1024086991"/>
+      </p:ext>
+    </p:extLst>
+  </p:cSld>
+  <p:clrMapOvr>
+    <a:masterClrMapping/>
+  </p:clrMapOvr>
+</p:notes>
+</file>
+
+<file path=ppt/notesSlides/notesSlide14.xml><?xml version="1.0" encoding="utf-8"?>
+<p:notes xmlns:a="http://schemas.openxmlformats.org/drawingml/2006/main" xmlns:r="http://schemas.openxmlformats.org/officeDocument/2006/relationships" xmlns:p="http://schemas.openxmlformats.org/presentationml/2006/main">
+  <p:cSld>
+    <p:spTree>
+      <p:nvGrpSpPr>
+        <p:cNvPr id="1" name=""/>
+        <p:cNvGrpSpPr/>
+        <p:nvPr/>
+      </p:nvGrpSpPr>
+      <p:grpSpPr>
+        <a:xfrm>
+          <a:off x="0" y="0"/>
+          <a:ext cx="0" cy="0"/>
+          <a:chOff x="0" y="0"/>
+          <a:chExt cx="0" cy="0"/>
+        </a:xfrm>
+      </p:grpSpPr>
+      <p:sp>
+        <p:nvSpPr>
+          <p:cNvPr id="2" name="Slide Image Placeholder 1"/>
+          <p:cNvSpPr>
+            <a:spLocks noGrp="1" noRot="1" noChangeAspect="1"/>
+          </p:cNvSpPr>
+          <p:nvPr>
+            <p:ph type="sldImg"/>
+          </p:nvPr>
+        </p:nvSpPr>
+        <p:spPr/>
+      </p:sp>
+      <p:sp>
+        <p:nvSpPr>
+          <p:cNvPr id="3" name="Notes Placeholder 2"/>
+          <p:cNvSpPr>
+            <a:spLocks noGrp="1"/>
+          </p:cNvSpPr>
+          <p:nvPr>
+            <p:ph type="body" idx="1"/>
+          </p:nvPr>
+        </p:nvSpPr>
+        <p:spPr/>
+        <p:txBody>
+          <a:bodyPr/>
+          <a:lstStyle/>
+          <a:p>
+            <a:r>
+              <a:rPr lang="en-US" dirty="0"/>
+              <a:t/>
+            </a:r>
+            <a:endParaRPr lang="en-US" dirty="0"/>
+          </a:p>
+        </p:txBody>
+      </p:sp>
+      <p:sp>
+        <p:nvSpPr>
+          <p:cNvPr id="4" name="Slide Number Placeholder 3"/>
+          <p:cNvSpPr>
+            <a:spLocks noGrp="1"/>
+          </p:cNvSpPr>
+          <p:nvPr>
+            <p:ph type="sldNum" sz="quarter" idx="10"/>
+          </p:nvPr>
+        </p:nvSpPr>
+        <p:spPr/>
+        <p:txBody>
+          <a:bodyPr/>
+          <a:lstStyle/>
+          <a:p>
+            <a:fld id="{F7021451-1387-4CA6-816F-3879F97B5CBC}" type="slidenum">
+              <a:rPr lang="en-US"/>
+              <a:t>14</a:t>
             </a:fld>
             <a:endParaRPr lang="en-US"/>
           </a:p>
@@ -3606,7 +3695,7 @@
                 <a:ea typeface="Meiryo" pitchFamily="34" charset="-122"/>
                 <a:cs typeface="Meiryo" pitchFamily="34" charset="-120"/>
               </a:rPr>
-              <a:t>現在の状況と今後</a:t>
+              <a:t>品質確認：ボードがなくても確かめられること</a:t>
             </a:r>
             <a:endParaRPr lang="en-US" sz="2400" dirty="0"/>
           </a:p>
@@ -3645,7 +3734,7 @@
                 <a:ea typeface="Meiryo" pitchFamily="34" charset="-122"/>
                 <a:cs typeface="Meiryo" pitchFamily="34" charset="-120"/>
               </a:rPr>
-              <a:t>開発途中で貸与ボードの LCD が故障。事務局のご了承のもと、代替機到着後に更新版を提出</a:t>
+              <a:t>実機確認の前に、ビルドと判定ロジックを検証</a:t>
             </a:r>
             <a:endParaRPr lang="en-US" sz="1200" dirty="0"/>
           </a:p>
@@ -3659,452 +3748,12 @@
         </p:nvSpPr>
         <p:spPr>
           <a:xfrm>
-            <a:off x="457200" y="1371600"/>
-            <a:ext cx="411480" cy="411480"/>
-          </a:xfrm>
-          <a:prstGeom prst="ellipse">
-            <a:avLst/>
-          </a:prstGeom>
-          <a:solidFill>
-            <a:srgbClr val="3E9E6B"/>
-          </a:solidFill>
-          <a:ln w="12700">
-            <a:solidFill>
-              <a:srgbClr val="3E9E6B"/>
-            </a:solidFill>
-            <a:prstDash val="solid"/>
-          </a:ln>
-        </p:spPr>
-      </p:sp>
-      <p:pic>
-        <p:nvPicPr>
-          <p:cNvPr id="5" name="Image 0" descr="preencoded.png">    </p:cNvPr>
-          <p:cNvPicPr>
-            <a:picLocks noChangeAspect="1"/>
-          </p:cNvPicPr>
-          <p:nvPr/>
-        </p:nvPicPr>
-        <p:blipFill>
-          <a:blip r:embed="rId1"/>
-          <a:stretch>
-            <a:fillRect/>
-          </a:stretch>
-        </p:blipFill>
-        <p:spPr>
-          <a:xfrm>
-            <a:off x="547726" y="1462126"/>
-            <a:ext cx="230429" cy="230429"/>
-          </a:xfrm>
-          <a:prstGeom prst="rect">
-            <a:avLst/>
-          </a:prstGeom>
-        </p:spPr>
-      </p:pic>
-      <p:sp>
-        <p:nvSpPr>
-          <p:cNvPr id="6" name="Text 3"/>
-          <p:cNvSpPr txBox="1"/>
-          <p:nvPr/>
-        </p:nvSpPr>
-        <p:spPr>
-          <a:xfrm>
-            <a:off x="1005840" y="1371600"/>
-            <a:ext cx="4023360" cy="502920"/>
-          </a:xfrm>
-          <a:prstGeom prst="rect">
-            <a:avLst/>
-          </a:prstGeom>
-          <a:noFill/>
-          <a:ln/>
-        </p:spPr>
-        <p:txBody>
-          <a:bodyPr wrap="square" lIns="0" tIns="0" rIns="0" bIns="0" rtlCol="0" anchor="ctr"/>
-          <a:lstStyle/>
-          <a:p>
-            <a:pPr indent="0" marL="0">
-              <a:buNone/>
-            </a:pPr>
-            <a:r>
-              <a:rPr lang="en-US" sz="1050" dirty="0">
-                <a:solidFill>
-                  <a:srgbClr val="1B2B30"/>
-                </a:solidFill>
-                <a:latin typeface="Meiryo" pitchFamily="34" charset="0"/>
-                <a:ea typeface="Meiryo" pitchFamily="34" charset="-122"/>
-                <a:cs typeface="Meiryo" pitchFamily="34" charset="-120"/>
-              </a:rPr>
-              <a:t>μT-Kernel 3.0 起動・複数タスク・LED・シリアル出力（実機確認）</a:t>
-            </a:r>
-            <a:endParaRPr lang="en-US" sz="1050" dirty="0"/>
-          </a:p>
-        </p:txBody>
-      </p:sp>
-      <p:sp>
-        <p:nvSpPr>
-          <p:cNvPr id="7" name="Shape 4"/>
-          <p:cNvSpPr/>
-          <p:nvPr/>
-        </p:nvSpPr>
-        <p:spPr>
-          <a:xfrm>
-            <a:off x="457200" y="1975104"/>
-            <a:ext cx="411480" cy="411480"/>
-          </a:xfrm>
-          <a:prstGeom prst="ellipse">
-            <a:avLst/>
-          </a:prstGeom>
-          <a:solidFill>
-            <a:srgbClr val="3E9E6B"/>
-          </a:solidFill>
-          <a:ln w="12700">
-            <a:solidFill>
-              <a:srgbClr val="3E9E6B"/>
-            </a:solidFill>
-            <a:prstDash val="solid"/>
-          </a:ln>
-        </p:spPr>
-      </p:sp>
-      <p:pic>
-        <p:nvPicPr>
-          <p:cNvPr id="8" name="Image 1" descr="preencoded.png">    </p:cNvPr>
-          <p:cNvPicPr>
-            <a:picLocks noChangeAspect="1"/>
-          </p:cNvPicPr>
-          <p:nvPr/>
-        </p:nvPicPr>
-        <p:blipFill>
-          <a:blip r:embed="rId2"/>
-          <a:stretch>
-            <a:fillRect/>
-          </a:stretch>
-        </p:blipFill>
-        <p:spPr>
-          <a:xfrm>
-            <a:off x="547726" y="2065630"/>
-            <a:ext cx="230429" cy="230429"/>
-          </a:xfrm>
-          <a:prstGeom prst="rect">
-            <a:avLst/>
-          </a:prstGeom>
-        </p:spPr>
-      </p:pic>
-      <p:sp>
-        <p:nvSpPr>
-          <p:cNvPr id="9" name="Text 5"/>
-          <p:cNvSpPr txBox="1"/>
-          <p:nvPr/>
-        </p:nvSpPr>
-        <p:spPr>
-          <a:xfrm>
-            <a:off x="1005840" y="1975104"/>
-            <a:ext cx="4023360" cy="502920"/>
-          </a:xfrm>
-          <a:prstGeom prst="rect">
-            <a:avLst/>
-          </a:prstGeom>
-          <a:noFill/>
-          <a:ln/>
-        </p:spPr>
-        <p:txBody>
-          <a:bodyPr wrap="square" lIns="0" tIns="0" rIns="0" bIns="0" rtlCol="0" anchor="ctr"/>
-          <a:lstStyle/>
-          <a:p>
-            <a:pPr indent="0" marL="0">
-              <a:buNone/>
-            </a:pPr>
-            <a:r>
-              <a:rPr lang="en-US" sz="1050" dirty="0">
-                <a:solidFill>
-                  <a:srgbClr val="1B2B30"/>
-                </a:solidFill>
-                <a:latin typeface="Meiryo" pitchFamily="34" charset="0"/>
-                <a:ea typeface="Meiryo" pitchFamily="34" charset="-122"/>
-                <a:cs typeface="Meiryo" pitchFamily="34" charset="-120"/>
-              </a:rPr>
-              <a:t>公式 AI サンプルの実機動作（カメラ約30fps／推論約20回/秒）</a:t>
-            </a:r>
-            <a:endParaRPr lang="en-US" sz="1050" dirty="0"/>
-          </a:p>
-        </p:txBody>
-      </p:sp>
-      <p:sp>
-        <p:nvSpPr>
-          <p:cNvPr id="10" name="Shape 6"/>
-          <p:cNvSpPr/>
-          <p:nvPr/>
-        </p:nvSpPr>
-        <p:spPr>
-          <a:xfrm>
-            <a:off x="457200" y="2578608"/>
-            <a:ext cx="411480" cy="411480"/>
-          </a:xfrm>
-          <a:prstGeom prst="ellipse">
-            <a:avLst/>
-          </a:prstGeom>
-          <a:solidFill>
-            <a:srgbClr val="3E9E6B"/>
-          </a:solidFill>
-          <a:ln w="12700">
-            <a:solidFill>
-              <a:srgbClr val="3E9E6B"/>
-            </a:solidFill>
-            <a:prstDash val="solid"/>
-          </a:ln>
-        </p:spPr>
-      </p:sp>
-      <p:pic>
-        <p:nvPicPr>
-          <p:cNvPr id="11" name="Image 2" descr="preencoded.png">    </p:cNvPr>
-          <p:cNvPicPr>
-            <a:picLocks noChangeAspect="1"/>
-          </p:cNvPicPr>
-          <p:nvPr/>
-        </p:nvPicPr>
-        <p:blipFill>
-          <a:blip r:embed="rId3"/>
-          <a:stretch>
-            <a:fillRect/>
-          </a:stretch>
-        </p:blipFill>
-        <p:spPr>
-          <a:xfrm>
-            <a:off x="547726" y="2669134"/>
-            <a:ext cx="230429" cy="230429"/>
-          </a:xfrm>
-          <a:prstGeom prst="rect">
-            <a:avLst/>
-          </a:prstGeom>
-        </p:spPr>
-      </p:pic>
-      <p:sp>
-        <p:nvSpPr>
-          <p:cNvPr id="12" name="Text 7"/>
-          <p:cNvSpPr txBox="1"/>
-          <p:nvPr/>
-        </p:nvSpPr>
-        <p:spPr>
-          <a:xfrm>
-            <a:off x="1005840" y="2578608"/>
-            <a:ext cx="4023360" cy="502920"/>
-          </a:xfrm>
-          <a:prstGeom prst="rect">
-            <a:avLst/>
-          </a:prstGeom>
-          <a:noFill/>
-          <a:ln/>
-        </p:spPr>
-        <p:txBody>
-          <a:bodyPr wrap="square" lIns="0" tIns="0" rIns="0" bIns="0" rtlCol="0" anchor="ctr"/>
-          <a:lstStyle/>
-          <a:p>
-            <a:pPr indent="0" marL="0">
-              <a:buNone/>
-            </a:pPr>
-            <a:r>
-              <a:rPr lang="en-US" sz="1050" dirty="0">
-                <a:solidFill>
-                  <a:srgbClr val="1B2B30"/>
-                </a:solidFill>
-                <a:latin typeface="Meiryo" pitchFamily="34" charset="0"/>
-                <a:ea typeface="Meiryo" pitchFamily="34" charset="-122"/>
-                <a:cs typeface="Meiryo" pitchFamily="34" charset="-120"/>
-              </a:rPr>
-              <a:t>互換レイヤー、FSP 設定・ピン修正、カメラ／AI タスク化</a:t>
-            </a:r>
-            <a:endParaRPr lang="en-US" sz="1050" dirty="0"/>
-          </a:p>
-        </p:txBody>
-      </p:sp>
-      <p:sp>
-        <p:nvSpPr>
-          <p:cNvPr id="13" name="Shape 8"/>
-          <p:cNvSpPr/>
-          <p:nvPr/>
-        </p:nvSpPr>
-        <p:spPr>
-          <a:xfrm>
-            <a:off x="457200" y="3182112"/>
-            <a:ext cx="411480" cy="411480"/>
-          </a:xfrm>
-          <a:prstGeom prst="ellipse">
-            <a:avLst/>
-          </a:prstGeom>
-          <a:solidFill>
-            <a:srgbClr val="E89B2F"/>
-          </a:solidFill>
-          <a:ln w="12700">
-            <a:solidFill>
-              <a:srgbClr val="E89B2F"/>
-            </a:solidFill>
-            <a:prstDash val="solid"/>
-          </a:ln>
-        </p:spPr>
-      </p:sp>
-      <p:pic>
-        <p:nvPicPr>
-          <p:cNvPr id="14" name="Image 3" descr="preencoded.png">    </p:cNvPr>
-          <p:cNvPicPr>
-            <a:picLocks noChangeAspect="1"/>
-          </p:cNvPicPr>
-          <p:nvPr/>
-        </p:nvPicPr>
-        <p:blipFill>
-          <a:blip r:embed="rId4"/>
-          <a:stretch>
-            <a:fillRect/>
-          </a:stretch>
-        </p:blipFill>
-        <p:spPr>
-          <a:xfrm>
-            <a:off x="547726" y="3272638"/>
-            <a:ext cx="230429" cy="230429"/>
-          </a:xfrm>
-          <a:prstGeom prst="rect">
-            <a:avLst/>
-          </a:prstGeom>
-        </p:spPr>
-      </p:pic>
-      <p:sp>
-        <p:nvSpPr>
-          <p:cNvPr id="15" name="Text 9"/>
-          <p:cNvSpPr txBox="1"/>
-          <p:nvPr/>
-        </p:nvSpPr>
-        <p:spPr>
-          <a:xfrm>
-            <a:off x="1005840" y="3182112"/>
-            <a:ext cx="4023360" cy="502920"/>
-          </a:xfrm>
-          <a:prstGeom prst="rect">
-            <a:avLst/>
-          </a:prstGeom>
-          <a:noFill/>
-          <a:ln/>
-        </p:spPr>
-        <p:txBody>
-          <a:bodyPr wrap="square" lIns="0" tIns="0" rIns="0" bIns="0" rtlCol="0" anchor="ctr"/>
-          <a:lstStyle/>
-          <a:p>
-            <a:pPr indent="0" marL="0">
-              <a:buNone/>
-            </a:pPr>
-            <a:r>
-              <a:rPr lang="en-US" sz="1050" dirty="0">
-                <a:solidFill>
-                  <a:srgbClr val="1B2B30"/>
-                </a:solidFill>
-                <a:latin typeface="Meiryo" pitchFamily="34" charset="0"/>
-                <a:ea typeface="Meiryo" pitchFamily="34" charset="-122"/>
-                <a:cs typeface="Meiryo" pitchFamily="34" charset="-120"/>
-              </a:rPr>
-              <a:t>μT-Kernel 版の LCD 表示確認（故障のため代替機待ち）</a:t>
-            </a:r>
-            <a:endParaRPr lang="en-US" sz="1050" dirty="0"/>
-          </a:p>
-        </p:txBody>
-      </p:sp>
-      <p:sp>
-        <p:nvSpPr>
-          <p:cNvPr id="16" name="Shape 10"/>
-          <p:cNvSpPr/>
-          <p:nvPr/>
-        </p:nvSpPr>
-        <p:spPr>
-          <a:xfrm>
-            <a:off x="457200" y="3785616"/>
-            <a:ext cx="411480" cy="411480"/>
-          </a:xfrm>
-          <a:prstGeom prst="ellipse">
-            <a:avLst/>
-          </a:prstGeom>
-          <a:solidFill>
-            <a:srgbClr val="5B6B70"/>
-          </a:solidFill>
-          <a:ln w="12700">
-            <a:solidFill>
-              <a:srgbClr val="5B6B70"/>
-            </a:solidFill>
-            <a:prstDash val="solid"/>
-          </a:ln>
-        </p:spPr>
-      </p:sp>
-      <p:pic>
-        <p:nvPicPr>
-          <p:cNvPr id="17" name="Image 4" descr="preencoded.png">    </p:cNvPr>
-          <p:cNvPicPr>
-            <a:picLocks noChangeAspect="1"/>
-          </p:cNvPicPr>
-          <p:nvPr/>
-        </p:nvPicPr>
-        <p:blipFill>
-          <a:blip r:embed="rId5"/>
-          <a:stretch>
-            <a:fillRect/>
-          </a:stretch>
-        </p:blipFill>
-        <p:spPr>
-          <a:xfrm>
-            <a:off x="547726" y="3876142"/>
-            <a:ext cx="230429" cy="230429"/>
-          </a:xfrm>
-          <a:prstGeom prst="rect">
-            <a:avLst/>
-          </a:prstGeom>
-        </p:spPr>
-      </p:pic>
-      <p:sp>
-        <p:nvSpPr>
-          <p:cNvPr id="18" name="Text 11"/>
-          <p:cNvSpPr txBox="1"/>
-          <p:nvPr/>
-        </p:nvSpPr>
-        <p:spPr>
-          <a:xfrm>
-            <a:off x="1005840" y="3785616"/>
-            <a:ext cx="4023360" cy="502920"/>
-          </a:xfrm>
-          <a:prstGeom prst="rect">
-            <a:avLst/>
-          </a:prstGeom>
-          <a:noFill/>
-          <a:ln/>
-        </p:spPr>
-        <p:txBody>
-          <a:bodyPr wrap="square" lIns="0" tIns="0" rIns="0" bIns="0" rtlCol="0" anchor="ctr"/>
-          <a:lstStyle/>
-          <a:p>
-            <a:pPr indent="0" marL="0">
-              <a:buNone/>
-            </a:pPr>
-            <a:r>
-              <a:rPr lang="en-US" sz="1050" dirty="0">
-                <a:solidFill>
-                  <a:srgbClr val="1B2B30"/>
-                </a:solidFill>
-                <a:latin typeface="Meiryo" pitchFamily="34" charset="0"/>
-                <a:ea typeface="Meiryo" pitchFamily="34" charset="-122"/>
-                <a:cs typeface="Meiryo" pitchFamily="34" charset="-120"/>
-              </a:rPr>
-              <a:t>6タスク化・転倒判定・プライバシー UI（設計済み）</a:t>
-            </a:r>
-            <a:endParaRPr lang="en-US" sz="1050" dirty="0"/>
-          </a:p>
-        </p:txBody>
-      </p:sp>
-      <p:sp>
-        <p:nvSpPr>
-          <p:cNvPr id="19" name="Shape 12"/>
-          <p:cNvSpPr/>
-          <p:nvPr/>
-        </p:nvSpPr>
-        <p:spPr>
-          <a:xfrm>
-            <a:off x="5212080" y="1325880"/>
-            <a:ext cx="3474720" cy="3154680"/>
+            <a:off x="457200" y="1325880"/>
+            <a:ext cx="2606040" cy="1463040"/>
           </a:xfrm>
           <a:prstGeom prst="roundRect">
             <a:avLst>
-              <a:gd name="adj" fmla="val 2319"/>
+              <a:gd name="adj" fmla="val 5000"/>
             </a:avLst>
           </a:prstGeom>
           <a:solidFill>
@@ -4120,14 +3769,14 @@
       </p:sp>
       <p:sp>
         <p:nvSpPr>
-          <p:cNvPr id="20" name="Text 13"/>
+          <p:cNvPr id="5" name="Text 3"/>
           <p:cNvSpPr txBox="1"/>
           <p:nvPr/>
         </p:nvSpPr>
         <p:spPr>
           <a:xfrm>
-            <a:off x="5394960" y="1463040"/>
-            <a:ext cx="3108960" cy="365760"/>
+            <a:off x="640080" y="1417320"/>
+            <a:ext cx="2240280" cy="685800"/>
           </a:xfrm>
           <a:prstGeom prst="rect">
             <a:avLst/>
@@ -4143,40 +3792,98 @@
               <a:buNone/>
             </a:pPr>
             <a:r>
-              <a:rPr lang="en-US" sz="1400" b="1" dirty="0">
-                <a:solidFill>
-                  <a:srgbClr val="0F2A33"/>
+              <a:rPr lang="en-US" sz="3200" b="1" dirty="0">
+                <a:solidFill>
+                  <a:srgbClr val="1F6F78"/>
+                </a:solidFill>
+                <a:latin typeface="Arial" pitchFamily="34" charset="0"/>
+                <a:ea typeface="Arial" pitchFamily="34" charset="-122"/>
+                <a:cs typeface="Arial" pitchFamily="34" charset="-120"/>
+              </a:rPr>
+              <a:t>1086</a:t>
+            </a:r>
+            <a:endParaRPr lang="en-US" sz="3200" dirty="0"/>
+          </a:p>
+        </p:txBody>
+      </p:sp>
+      <p:sp>
+        <p:nvSpPr>
+          <p:cNvPr id="6" name="Text 4"/>
+          <p:cNvSpPr txBox="1"/>
+          <p:nvPr/>
+        </p:nvSpPr>
+        <p:spPr>
+          <a:xfrm>
+            <a:off x="640080" y="2103120"/>
+            <a:ext cx="2240280" cy="594360"/>
+          </a:xfrm>
+          <a:prstGeom prst="rect">
+            <a:avLst/>
+          </a:prstGeom>
+          <a:noFill/>
+          <a:ln/>
+        </p:spPr>
+        <p:txBody>
+          <a:bodyPr wrap="square" lIns="0" tIns="0" rIns="0" bIns="0" rtlCol="0" anchor="ctr"/>
+          <a:lstStyle/>
+          <a:p>
+            <a:pPr indent="0" marL="0">
+              <a:buNone/>
+            </a:pPr>
+            <a:r>
+              <a:rPr lang="en-US" sz="1050" dirty="0">
+                <a:solidFill>
+                  <a:srgbClr val="1B2B30"/>
                 </a:solidFill>
                 <a:latin typeface="Meiryo" pitchFamily="34" charset="0"/>
                 <a:ea typeface="Meiryo" pitchFamily="34" charset="-122"/>
                 <a:cs typeface="Meiryo" pitchFamily="34" charset="-120"/>
               </a:rPr>
-              <a:t>代替機到着後の予定</a:t>
-            </a:r>
-            <a:endParaRPr lang="en-US" sz="1400" dirty="0"/>
-          </a:p>
-        </p:txBody>
-      </p:sp>
-      <p:sp>
-        <p:nvSpPr>
-          <p:cNvPr id="21" name="Shape 14"/>
+              <a:t>ファイルを GCC 13.2.1 で</a:t>
+            </a:r>
+            <a:endParaRPr lang="en-US" sz="1050" dirty="0"/>
+          </a:p>
+          <a:p>
+            <a:pPr indent="0" marL="0">
+              <a:buNone/>
+            </a:pPr>
+            <a:r>
+              <a:rPr lang="en-US" sz="1050" dirty="0">
+                <a:solidFill>
+                  <a:srgbClr val="1B2B30"/>
+                </a:solidFill>
+                <a:latin typeface="Meiryo" pitchFamily="34" charset="0"/>
+                <a:ea typeface="Meiryo" pitchFamily="34" charset="-122"/>
+                <a:cs typeface="Meiryo" pitchFamily="34" charset="-120"/>
+              </a:rPr>
+              <a:t>コンパイル・リンク成功</a:t>
+            </a:r>
+            <a:endParaRPr lang="en-US" sz="1050" dirty="0"/>
+          </a:p>
+        </p:txBody>
+      </p:sp>
+      <p:sp>
+        <p:nvSpPr>
+          <p:cNvPr id="7" name="Shape 5"/>
           <p:cNvSpPr/>
           <p:nvPr/>
         </p:nvSpPr>
         <p:spPr>
           <a:xfrm>
-            <a:off x="5394960" y="1965960"/>
-            <a:ext cx="329184" cy="329184"/>
-          </a:xfrm>
-          <a:prstGeom prst="ellipse">
-            <a:avLst/>
+            <a:off x="3291840" y="1325880"/>
+            <a:ext cx="2606040" cy="1463040"/>
+          </a:xfrm>
+          <a:prstGeom prst="roundRect">
+            <a:avLst>
+              <a:gd name="adj" fmla="val 5000"/>
+            </a:avLst>
           </a:prstGeom>
           <a:solidFill>
-            <a:srgbClr val="1F6F78"/>
+            <a:srgbClr val="E3F0F1"/>
           </a:solidFill>
-          <a:ln w="12700">
+          <a:ln w="9525">
             <a:solidFill>
-              <a:srgbClr val="1F6F78"/>
+              <a:srgbClr val="C9D6D8"/>
             </a:solidFill>
             <a:prstDash val="solid"/>
           </a:ln>
@@ -4184,14 +3891,14 @@
       </p:sp>
       <p:sp>
         <p:nvSpPr>
-          <p:cNvPr id="22" name="Text 15"/>
+          <p:cNvPr id="8" name="Text 6"/>
           <p:cNvSpPr txBox="1"/>
           <p:nvPr/>
         </p:nvSpPr>
         <p:spPr>
           <a:xfrm>
-            <a:off x="5394960" y="1965960"/>
-            <a:ext cx="329184" cy="329184"/>
+            <a:off x="3474720" y="1417320"/>
+            <a:ext cx="2240280" cy="685800"/>
           </a:xfrm>
           <a:prstGeom prst="rect">
             <a:avLst/>
@@ -4203,34 +3910,34 @@
           <a:bodyPr wrap="square" lIns="0" tIns="0" rIns="0" bIns="0" rtlCol="0" anchor="ctr"/>
           <a:lstStyle/>
           <a:p>
-            <a:pPr algn="ctr" indent="0" marL="0">
+            <a:pPr indent="0" marL="0">
               <a:buNone/>
             </a:pPr>
             <a:r>
-              <a:rPr lang="en-US" sz="1100" b="1" dirty="0">
-                <a:solidFill>
-                  <a:srgbClr val="FFFFFF"/>
+              <a:rPr lang="en-US" sz="3200" b="1" dirty="0">
+                <a:solidFill>
+                  <a:srgbClr val="1F6F78"/>
                 </a:solidFill>
                 <a:latin typeface="Arial" pitchFamily="34" charset="0"/>
                 <a:ea typeface="Arial" pitchFamily="34" charset="-122"/>
                 <a:cs typeface="Arial" pitchFamily="34" charset="-120"/>
               </a:rPr>
-              <a:t>1</a:t>
-            </a:r>
-            <a:endParaRPr lang="en-US" sz="1100" dirty="0"/>
-          </a:p>
-        </p:txBody>
-      </p:sp>
-      <p:sp>
-        <p:nvSpPr>
-          <p:cNvPr id="23" name="Text 16"/>
+              <a:t>0</a:t>
+            </a:r>
+            <a:endParaRPr lang="en-US" sz="3200" dirty="0"/>
+          </a:p>
+        </p:txBody>
+      </p:sp>
+      <p:sp>
+        <p:nvSpPr>
+          <p:cNvPr id="9" name="Text 7"/>
           <p:cNvSpPr txBox="1"/>
           <p:nvPr/>
         </p:nvSpPr>
         <p:spPr>
           <a:xfrm>
-            <a:off x="5852160" y="1920240"/>
-            <a:ext cx="2743200" cy="420624"/>
+            <a:off x="3474720" y="2103120"/>
+            <a:ext cx="2240280" cy="594360"/>
           </a:xfrm>
           <a:prstGeom prst="rect">
             <a:avLst/>
@@ -4246,7 +3953,7 @@
               <a:buNone/>
             </a:pPr>
             <a:r>
-              <a:rPr lang="en-US" sz="1100" dirty="0">
+              <a:rPr lang="en-US" sz="1050" dirty="0">
                 <a:solidFill>
                   <a:srgbClr val="1B2B30"/>
                 </a:solidFill>
@@ -4254,32 +3961,51 @@
                 <a:ea typeface="Meiryo" pitchFamily="34" charset="-122"/>
                 <a:cs typeface="Meiryo" pitchFamily="34" charset="-120"/>
               </a:rPr>
-              <a:t>LCD を含む実機動作確認</a:t>
-            </a:r>
-            <a:endParaRPr lang="en-US" sz="1100" dirty="0"/>
-          </a:p>
-        </p:txBody>
-      </p:sp>
-      <p:sp>
-        <p:nvSpPr>
-          <p:cNvPr id="24" name="Shape 17"/>
+              <a:t>自作コードの</a:t>
+            </a:r>
+            <a:endParaRPr lang="en-US" sz="1050" dirty="0"/>
+          </a:p>
+          <a:p>
+            <a:pPr indent="0" marL="0">
+              <a:buNone/>
+            </a:pPr>
+            <a:r>
+              <a:rPr lang="en-US" sz="1050" dirty="0">
+                <a:solidFill>
+                  <a:srgbClr val="1B2B30"/>
+                </a:solidFill>
+                <a:latin typeface="Meiryo" pitchFamily="34" charset="0"/>
+                <a:ea typeface="Meiryo" pitchFamily="34" charset="-122"/>
+                <a:cs typeface="Meiryo" pitchFamily="34" charset="-120"/>
+              </a:rPr>
+              <a:t>コンパイラ警告（-Wall）</a:t>
+            </a:r>
+            <a:endParaRPr lang="en-US" sz="1050" dirty="0"/>
+          </a:p>
+        </p:txBody>
+      </p:sp>
+      <p:sp>
+        <p:nvSpPr>
+          <p:cNvPr id="10" name="Shape 8"/>
           <p:cNvSpPr/>
           <p:nvPr/>
         </p:nvSpPr>
         <p:spPr>
           <a:xfrm>
-            <a:off x="5394960" y="2468880"/>
-            <a:ext cx="329184" cy="329184"/>
-          </a:xfrm>
-          <a:prstGeom prst="ellipse">
-            <a:avLst/>
+            <a:off x="6126480" y="1325880"/>
+            <a:ext cx="2606040" cy="1463040"/>
+          </a:xfrm>
+          <a:prstGeom prst="roundRect">
+            <a:avLst>
+              <a:gd name="adj" fmla="val 5000"/>
+            </a:avLst>
           </a:prstGeom>
           <a:solidFill>
-            <a:srgbClr val="1F6F78"/>
+            <a:srgbClr val="E3F0F1"/>
           </a:solidFill>
-          <a:ln w="12700">
+          <a:ln w="9525">
             <a:solidFill>
-              <a:srgbClr val="1F6F78"/>
+              <a:srgbClr val="C9D6D8"/>
             </a:solidFill>
             <a:prstDash val="solid"/>
           </a:ln>
@@ -4287,14 +4013,14 @@
       </p:sp>
       <p:sp>
         <p:nvSpPr>
-          <p:cNvPr id="25" name="Text 18"/>
+          <p:cNvPr id="11" name="Text 9"/>
           <p:cNvSpPr txBox="1"/>
           <p:nvPr/>
         </p:nvSpPr>
         <p:spPr>
           <a:xfrm>
-            <a:off x="5394960" y="2468880"/>
-            <a:ext cx="329184" cy="329184"/>
+            <a:off x="6309360" y="1417320"/>
+            <a:ext cx="2240280" cy="685800"/>
           </a:xfrm>
           <a:prstGeom prst="rect">
             <a:avLst/>
@@ -4306,34 +4032,34 @@
           <a:bodyPr wrap="square" lIns="0" tIns="0" rIns="0" bIns="0" rtlCol="0" anchor="ctr"/>
           <a:lstStyle/>
           <a:p>
-            <a:pPr algn="ctr" indent="0" marL="0">
+            <a:pPr indent="0" marL="0">
               <a:buNone/>
             </a:pPr>
             <a:r>
-              <a:rPr lang="en-US" sz="1100" b="1" dirty="0">
-                <a:solidFill>
-                  <a:srgbClr val="FFFFFF"/>
+              <a:rPr lang="en-US" sz="3200" b="1" dirty="0">
+                <a:solidFill>
+                  <a:srgbClr val="1F6F78"/>
                 </a:solidFill>
                 <a:latin typeface="Arial" pitchFamily="34" charset="0"/>
                 <a:ea typeface="Arial" pitchFamily="34" charset="-122"/>
                 <a:cs typeface="Arial" pitchFamily="34" charset="-120"/>
               </a:rPr>
-              <a:t>2</a:t>
-            </a:r>
-            <a:endParaRPr lang="en-US" sz="1100" dirty="0"/>
-          </a:p>
-        </p:txBody>
-      </p:sp>
-      <p:sp>
-        <p:nvSpPr>
-          <p:cNvPr id="26" name="Text 19"/>
+              <a:t>13/13</a:t>
+            </a:r>
+            <a:endParaRPr lang="en-US" sz="3200" dirty="0"/>
+          </a:p>
+        </p:txBody>
+      </p:sp>
+      <p:sp>
+        <p:nvSpPr>
+          <p:cNvPr id="12" name="Text 10"/>
           <p:cNvSpPr txBox="1"/>
           <p:nvPr/>
         </p:nvSpPr>
         <p:spPr>
           <a:xfrm>
-            <a:off x="5852160" y="2423160"/>
-            <a:ext cx="2743200" cy="420624"/>
+            <a:off x="6309360" y="2103120"/>
+            <a:ext cx="2240280" cy="594360"/>
           </a:xfrm>
           <a:prstGeom prst="rect">
             <a:avLst/>
@@ -4349,7 +4075,7 @@
               <a:buNone/>
             </a:pPr>
             <a:r>
-              <a:rPr lang="en-US" sz="1100" dirty="0">
+              <a:rPr lang="en-US" sz="1050" dirty="0">
                 <a:solidFill>
                   <a:srgbClr val="1B2B30"/>
                 </a:solidFill>
@@ -4357,102 +4083,16 @@
                 <a:ea typeface="Meiryo" pitchFamily="34" charset="-122"/>
                 <a:cs typeface="Meiryo" pitchFamily="34" charset="-120"/>
               </a:rPr>
-              <a:t>6タスク構成へ拡張</a:t>
-            </a:r>
-            <a:endParaRPr lang="en-US" sz="1100" dirty="0"/>
-          </a:p>
-        </p:txBody>
-      </p:sp>
-      <p:sp>
-        <p:nvSpPr>
-          <p:cNvPr id="27" name="Shape 20"/>
-          <p:cNvSpPr/>
-          <p:nvPr/>
-        </p:nvSpPr>
-        <p:spPr>
-          <a:xfrm>
-            <a:off x="5394960" y="2971800"/>
-            <a:ext cx="329184" cy="329184"/>
-          </a:xfrm>
-          <a:prstGeom prst="ellipse">
-            <a:avLst/>
-          </a:prstGeom>
-          <a:solidFill>
-            <a:srgbClr val="1F6F78"/>
-          </a:solidFill>
-          <a:ln w="12700">
-            <a:solidFill>
-              <a:srgbClr val="1F6F78"/>
-            </a:solidFill>
-            <a:prstDash val="solid"/>
-          </a:ln>
-        </p:spPr>
-      </p:sp>
-      <p:sp>
-        <p:nvSpPr>
-          <p:cNvPr id="28" name="Text 21"/>
-          <p:cNvSpPr txBox="1"/>
-          <p:nvPr/>
-        </p:nvSpPr>
-        <p:spPr>
-          <a:xfrm>
-            <a:off x="5394960" y="2971800"/>
-            <a:ext cx="329184" cy="329184"/>
-          </a:xfrm>
-          <a:prstGeom prst="rect">
-            <a:avLst/>
-          </a:prstGeom>
-          <a:noFill/>
-          <a:ln/>
-        </p:spPr>
-        <p:txBody>
-          <a:bodyPr wrap="square" lIns="0" tIns="0" rIns="0" bIns="0" rtlCol="0" anchor="ctr"/>
-          <a:lstStyle/>
-          <a:p>
-            <a:pPr algn="ctr" indent="0" marL="0">
-              <a:buNone/>
-            </a:pPr>
-            <a:r>
-              <a:rPr lang="en-US" sz="1100" b="1" dirty="0">
-                <a:solidFill>
-                  <a:srgbClr val="FFFFFF"/>
-                </a:solidFill>
-                <a:latin typeface="Arial" pitchFamily="34" charset="0"/>
-                <a:ea typeface="Arial" pitchFamily="34" charset="-122"/>
-                <a:cs typeface="Arial" pitchFamily="34" charset="-120"/>
-              </a:rPr>
-              <a:t>3</a:t>
-            </a:r>
-            <a:endParaRPr lang="en-US" sz="1100" dirty="0"/>
-          </a:p>
-        </p:txBody>
-      </p:sp>
-      <p:sp>
-        <p:nvSpPr>
-          <p:cNvPr id="29" name="Text 22"/>
-          <p:cNvSpPr txBox="1"/>
-          <p:nvPr/>
-        </p:nvSpPr>
-        <p:spPr>
-          <a:xfrm>
-            <a:off x="5852160" y="2926080"/>
-            <a:ext cx="2743200" cy="420624"/>
-          </a:xfrm>
-          <a:prstGeom prst="rect">
-            <a:avLst/>
-          </a:prstGeom>
-          <a:noFill/>
-          <a:ln/>
-        </p:spPr>
-        <p:txBody>
-          <a:bodyPr wrap="square" lIns="0" tIns="0" rIns="0" bIns="0" rtlCol="0" anchor="ctr"/>
-          <a:lstStyle/>
+              <a:t>転倒判定の単体テスト</a:t>
+            </a:r>
+            <a:endParaRPr lang="en-US" sz="1050" dirty="0"/>
+          </a:p>
           <a:p>
             <a:pPr indent="0" marL="0">
               <a:buNone/>
             </a:pPr>
             <a:r>
-              <a:rPr lang="en-US" sz="1100" dirty="0">
+              <a:rPr lang="en-US" sz="1050" dirty="0">
                 <a:solidFill>
                   <a:srgbClr val="1B2B30"/>
                 </a:solidFill>
@@ -4460,221 +4100,1107 @@
                 <a:ea typeface="Meiryo" pitchFamily="34" charset="-122"/>
                 <a:cs typeface="Meiryo" pitchFamily="34" charset="-120"/>
               </a:rPr>
-              <a:t>転倒判定の実装・しきい値調整</a:t>
-            </a:r>
-            <a:endParaRPr lang="en-US" sz="1100" dirty="0"/>
-          </a:p>
-        </p:txBody>
-      </p:sp>
-      <p:sp>
-        <p:nvSpPr>
-          <p:cNvPr id="30" name="Shape 23"/>
-          <p:cNvSpPr/>
-          <p:nvPr/>
-        </p:nvSpPr>
-        <p:spPr>
-          <a:xfrm>
-            <a:off x="5394960" y="3474720"/>
-            <a:ext cx="329184" cy="329184"/>
-          </a:xfrm>
-          <a:prstGeom prst="ellipse">
-            <a:avLst/>
-          </a:prstGeom>
-          <a:solidFill>
-            <a:srgbClr val="1F6F78"/>
-          </a:solidFill>
-          <a:ln w="12700">
-            <a:solidFill>
-              <a:srgbClr val="1F6F78"/>
-            </a:solidFill>
-            <a:prstDash val="solid"/>
-          </a:ln>
-        </p:spPr>
-      </p:sp>
-      <p:sp>
-        <p:nvSpPr>
-          <p:cNvPr id="31" name="Text 24"/>
-          <p:cNvSpPr txBox="1"/>
-          <p:nvPr/>
-        </p:nvSpPr>
-        <p:spPr>
-          <a:xfrm>
-            <a:off x="5394960" y="3474720"/>
-            <a:ext cx="329184" cy="329184"/>
-          </a:xfrm>
-          <a:prstGeom prst="rect">
-            <a:avLst/>
-          </a:prstGeom>
-          <a:noFill/>
-          <a:ln/>
-        </p:spPr>
-        <p:txBody>
-          <a:bodyPr wrap="square" lIns="0" tIns="0" rIns="0" bIns="0" rtlCol="0" anchor="ctr"/>
-          <a:lstStyle/>
-          <a:p>
-            <a:pPr algn="ctr" indent="0" marL="0">
-              <a:buNone/>
-            </a:pPr>
-            <a:r>
-              <a:rPr lang="en-US" sz="1100" b="1" dirty="0">
-                <a:solidFill>
-                  <a:srgbClr val="FFFFFF"/>
-                </a:solidFill>
-                <a:latin typeface="Arial" pitchFamily="34" charset="0"/>
-                <a:ea typeface="Arial" pitchFamily="34" charset="-122"/>
-                <a:cs typeface="Arial" pitchFamily="34" charset="-120"/>
-              </a:rPr>
-              <a:t>4</a:t>
-            </a:r>
-            <a:endParaRPr lang="en-US" sz="1100" dirty="0"/>
-          </a:p>
-        </p:txBody>
-      </p:sp>
-      <p:sp>
-        <p:nvSpPr>
-          <p:cNvPr id="32" name="Text 25"/>
-          <p:cNvSpPr txBox="1"/>
-          <p:nvPr/>
-        </p:nvSpPr>
-        <p:spPr>
-          <a:xfrm>
-            <a:off x="5852160" y="3429000"/>
-            <a:ext cx="2743200" cy="420624"/>
-          </a:xfrm>
-          <a:prstGeom prst="rect">
-            <a:avLst/>
-          </a:prstGeom>
-          <a:noFill/>
-          <a:ln/>
-        </p:spPr>
-        <p:txBody>
-          <a:bodyPr wrap="square" lIns="0" tIns="0" rIns="0" bIns="0" rtlCol="0" anchor="ctr"/>
-          <a:lstStyle/>
-          <a:p>
-            <a:pPr indent="0" marL="0">
-              <a:buNone/>
-            </a:pPr>
-            <a:r>
-              <a:rPr lang="en-US" sz="1100" dirty="0">
-                <a:solidFill>
-                  <a:srgbClr val="1B2B30"/>
-                </a:solidFill>
-                <a:latin typeface="Meiryo" pitchFamily="34" charset="0"/>
-                <a:ea typeface="Meiryo" pitchFamily="34" charset="-122"/>
-                <a:cs typeface="Meiryo" pitchFamily="34" charset="-120"/>
-              </a:rPr>
-              <a:t>検知率・誤報率・遅延の計測</a:t>
-            </a:r>
-            <a:endParaRPr lang="en-US" sz="1100" dirty="0"/>
-          </a:p>
-        </p:txBody>
-      </p:sp>
-      <p:sp>
-        <p:nvSpPr>
-          <p:cNvPr id="33" name="Shape 26"/>
-          <p:cNvSpPr/>
-          <p:nvPr/>
-        </p:nvSpPr>
-        <p:spPr>
-          <a:xfrm>
-            <a:off x="5394960" y="3977640"/>
-            <a:ext cx="329184" cy="329184"/>
-          </a:xfrm>
-          <a:prstGeom prst="ellipse">
-            <a:avLst/>
-          </a:prstGeom>
-          <a:solidFill>
-            <a:srgbClr val="1F6F78"/>
-          </a:solidFill>
-          <a:ln w="12700">
-            <a:solidFill>
-              <a:srgbClr val="1F6F78"/>
-            </a:solidFill>
-            <a:prstDash val="solid"/>
-          </a:ln>
-        </p:spPr>
-      </p:sp>
-      <p:sp>
-        <p:nvSpPr>
-          <p:cNvPr id="34" name="Text 27"/>
-          <p:cNvSpPr txBox="1"/>
-          <p:nvPr/>
-        </p:nvSpPr>
-        <p:spPr>
-          <a:xfrm>
-            <a:off x="5394960" y="3977640"/>
-            <a:ext cx="329184" cy="329184"/>
-          </a:xfrm>
-          <a:prstGeom prst="rect">
-            <a:avLst/>
-          </a:prstGeom>
-          <a:noFill/>
-          <a:ln/>
-        </p:spPr>
-        <p:txBody>
-          <a:bodyPr wrap="square" lIns="0" tIns="0" rIns="0" bIns="0" rtlCol="0" anchor="ctr"/>
-          <a:lstStyle/>
-          <a:p>
-            <a:pPr algn="ctr" indent="0" marL="0">
-              <a:buNone/>
-            </a:pPr>
-            <a:r>
-              <a:rPr lang="en-US" sz="1100" b="1" dirty="0">
-                <a:solidFill>
-                  <a:srgbClr val="FFFFFF"/>
-                </a:solidFill>
-                <a:latin typeface="Arial" pitchFamily="34" charset="0"/>
-                <a:ea typeface="Arial" pitchFamily="34" charset="-122"/>
-                <a:cs typeface="Arial" pitchFamily="34" charset="-120"/>
-              </a:rPr>
-              <a:t>5</a:t>
-            </a:r>
-            <a:endParaRPr lang="en-US" sz="1100" dirty="0"/>
-          </a:p>
-        </p:txBody>
-      </p:sp>
-      <p:sp>
-        <p:nvSpPr>
-          <p:cNvPr id="35" name="Text 28"/>
-          <p:cNvSpPr txBox="1"/>
-          <p:nvPr/>
-        </p:nvSpPr>
-        <p:spPr>
-          <a:xfrm>
-            <a:off x="5852160" y="3931920"/>
-            <a:ext cx="2743200" cy="420624"/>
-          </a:xfrm>
-          <a:prstGeom prst="rect">
-            <a:avLst/>
-          </a:prstGeom>
-          <a:noFill/>
-          <a:ln/>
-        </p:spPr>
-        <p:txBody>
-          <a:bodyPr wrap="square" lIns="0" tIns="0" rIns="0" bIns="0" rtlCol="0" anchor="ctr"/>
-          <a:lstStyle/>
-          <a:p>
-            <a:pPr indent="0" marL="0">
-              <a:buNone/>
-            </a:pPr>
-            <a:r>
-              <a:rPr lang="en-US" sz="1100" dirty="0">
-                <a:solidFill>
-                  <a:srgbClr val="1B2B30"/>
-                </a:solidFill>
-                <a:latin typeface="Meiryo" pitchFamily="34" charset="0"/>
-                <a:ea typeface="Meiryo" pitchFamily="34" charset="-122"/>
-                <a:cs typeface="Meiryo" pitchFamily="34" charset="-120"/>
-              </a:rPr>
-              <a:t>人物検出モデルへの置き換え</a:t>
-            </a:r>
-            <a:endParaRPr lang="en-US" sz="1100" dirty="0"/>
-          </a:p>
-        </p:txBody>
-      </p:sp>
-      <p:sp>
-        <p:nvSpPr>
-          <p:cNvPr id="36" name="Text 29"/>
+              <a:t>（PC 上で実行）</a:t>
+            </a:r>
+            <a:endParaRPr lang="en-US" sz="1050" dirty="0"/>
+          </a:p>
+        </p:txBody>
+      </p:sp>
+      <p:graphicFrame>
+        <p:nvGraphicFramePr>
+          <p:cNvPr id="12" name="Table 0"/>
+          <p:cNvGraphicFramePr>
+            <a:graphicFrameLocks noGrp="1"/>
+          </p:cNvGraphicFramePr>
+          <p:nvPr>
+            <p:extLst>
+              <p:ext uri="{D42A27DB-BD31-4B8C-83A1-F6EECF244321}">
+                <p14:modId xmlns:p14="http://schemas.microsoft.com/office/powerpoint/2010/main" val="1579011935"/>
+              </p:ext>
+            </p:extLst>
+          </p:nvPr>
+        </p:nvGraphicFramePr>
+        <p:xfrm>
+          <a:off x="457200" y="3017520"/>
+          <a:ext cx="8229600" cy="914400"/>
+        </p:xfrm>
+        <a:graphic>
+          <a:graphicData uri="http://schemas.openxmlformats.org/drawingml/2006/table">
+            <a:tbl>
+              <a:tblPr/>
+              <a:tblGrid>
+                <a:gridCol w="2194560"/>
+                <a:gridCol w="1920240"/>
+                <a:gridCol w="2194560"/>
+                <a:gridCol w="1920240"/>
+              </a:tblGrid>
+              <a:tr h="347472">
+                <a:tc>
+                  <a:txBody>
+                    <a:bodyPr/>
+                    <a:lstStyle/>
+                    <a:p>
+                      <a:pPr indent="0" marL="0">
+                        <a:buNone/>
+                      </a:pPr>
+                      <a:r>
+                        <a:rPr lang="en-US" sz="1000" b="1" dirty="0">
+                          <a:solidFill>
+                            <a:srgbClr val="FFFFFF"/>
+                          </a:solidFill>
+                          <a:latin typeface="Meiryo" pitchFamily="34" charset="0"/>
+                          <a:ea typeface="Meiryo" pitchFamily="34" charset="-122"/>
+                          <a:cs typeface="Meiryo" pitchFamily="34" charset="-120"/>
+                        </a:rPr>
+                        <a:t>単体テストのシナリオ</a:t>
+                      </a:r>
+                      <a:endParaRPr lang="en-US" sz="1000" dirty="0">
+                        <a:latin typeface="Meiryo" charset="0"/>
+                        <a:ea typeface="Meiryo" charset="0"/>
+                        <a:cs typeface="Meiryo" charset="0"/>
+                      </a:endParaRPr>
+                    </a:p>
+                  </a:txBody>
+                  <a:tcPr marL="45720" marR="45720" marT="45720" marB="45720" anchor="ctr">
+                    <a:lnL w="6350" cap="flat" cmpd="sng" algn="ctr">
+                      <a:solidFill>
+                        <a:srgbClr val="C9D6D8"/>
+                      </a:solidFill>
+                      <a:prstDash val="solid"/>
+                      <a:round/>
+                      <a:headEnd type="none" w="med" len="med"/>
+                      <a:tailEnd type="none" w="med" len="med"/>
+                    </a:lnL>
+                    <a:lnR w="6350" cap="flat" cmpd="sng" algn="ctr">
+                      <a:solidFill>
+                        <a:srgbClr val="C9D6D8"/>
+                      </a:solidFill>
+                      <a:prstDash val="solid"/>
+                      <a:round/>
+                      <a:headEnd type="none" w="med" len="med"/>
+                      <a:tailEnd type="none" w="med" len="med"/>
+                    </a:lnR>
+                    <a:lnT w="6350" cap="flat" cmpd="sng" algn="ctr">
+                      <a:solidFill>
+                        <a:srgbClr val="C9D6D8"/>
+                      </a:solidFill>
+                      <a:prstDash val="solid"/>
+                      <a:round/>
+                      <a:headEnd type="none" w="med" len="med"/>
+                      <a:tailEnd type="none" w="med" len="med"/>
+                    </a:lnT>
+                    <a:lnB w="6350" cap="flat" cmpd="sng" algn="ctr">
+                      <a:solidFill>
+                        <a:srgbClr val="C9D6D8"/>
+                      </a:solidFill>
+                      <a:prstDash val="solid"/>
+                      <a:round/>
+                      <a:headEnd type="none" w="med" len="med"/>
+                      <a:tailEnd type="none" w="med" len="med"/>
+                    </a:lnB>
+                    <a:solidFill>
+                      <a:srgbClr val="0F2A33"/>
+                    </a:solidFill>
+                  </a:tcPr>
+                </a:tc>
+                <a:tc>
+                  <a:txBody>
+                    <a:bodyPr/>
+                    <a:lstStyle/>
+                    <a:p>
+                      <a:pPr indent="0" marL="0">
+                        <a:buNone/>
+                      </a:pPr>
+                      <a:r>
+                        <a:rPr lang="en-US" sz="1000" b="1" dirty="0">
+                          <a:solidFill>
+                            <a:srgbClr val="FFFFFF"/>
+                          </a:solidFill>
+                          <a:latin typeface="Meiryo" pitchFamily="34" charset="0"/>
+                          <a:ea typeface="Meiryo" pitchFamily="34" charset="-122"/>
+                          <a:cs typeface="Meiryo" pitchFamily="34" charset="-120"/>
+                        </a:rPr>
+                        <a:t>期待結果</a:t>
+                      </a:r>
+                      <a:endParaRPr lang="en-US" sz="1000" dirty="0">
+                        <a:latin typeface="Meiryo" charset="0"/>
+                        <a:ea typeface="Meiryo" charset="0"/>
+                        <a:cs typeface="Meiryo" charset="0"/>
+                      </a:endParaRPr>
+                    </a:p>
+                  </a:txBody>
+                  <a:tcPr marL="45720" marR="45720" marT="45720" marB="45720" anchor="ctr">
+                    <a:lnL w="6350" cap="flat" cmpd="sng" algn="ctr">
+                      <a:solidFill>
+                        <a:srgbClr val="C9D6D8"/>
+                      </a:solidFill>
+                      <a:prstDash val="solid"/>
+                      <a:round/>
+                      <a:headEnd type="none" w="med" len="med"/>
+                      <a:tailEnd type="none" w="med" len="med"/>
+                    </a:lnL>
+                    <a:lnR w="6350" cap="flat" cmpd="sng" algn="ctr">
+                      <a:solidFill>
+                        <a:srgbClr val="C9D6D8"/>
+                      </a:solidFill>
+                      <a:prstDash val="solid"/>
+                      <a:round/>
+                      <a:headEnd type="none" w="med" len="med"/>
+                      <a:tailEnd type="none" w="med" len="med"/>
+                    </a:lnR>
+                    <a:lnT w="6350" cap="flat" cmpd="sng" algn="ctr">
+                      <a:solidFill>
+                        <a:srgbClr val="C9D6D8"/>
+                      </a:solidFill>
+                      <a:prstDash val="solid"/>
+                      <a:round/>
+                      <a:headEnd type="none" w="med" len="med"/>
+                      <a:tailEnd type="none" w="med" len="med"/>
+                    </a:lnT>
+                    <a:lnB w="6350" cap="flat" cmpd="sng" algn="ctr">
+                      <a:solidFill>
+                        <a:srgbClr val="C9D6D8"/>
+                      </a:solidFill>
+                      <a:prstDash val="solid"/>
+                      <a:round/>
+                      <a:headEnd type="none" w="med" len="med"/>
+                      <a:tailEnd type="none" w="med" len="med"/>
+                    </a:lnB>
+                    <a:solidFill>
+                      <a:srgbClr val="0F2A33"/>
+                    </a:solidFill>
+                  </a:tcPr>
+                </a:tc>
+                <a:tc>
+                  <a:txBody>
+                    <a:bodyPr/>
+                    <a:lstStyle/>
+                    <a:p>
+                      <a:pPr indent="0" marL="0">
+                        <a:buNone/>
+                      </a:pPr>
+                      <a:r>
+                        <a:rPr lang="en-US" sz="1000" b="1" dirty="0">
+                          <a:solidFill>
+                            <a:srgbClr val="FFFFFF"/>
+                          </a:solidFill>
+                          <a:latin typeface="Meiryo" pitchFamily="34" charset="0"/>
+                          <a:ea typeface="Meiryo" pitchFamily="34" charset="-122"/>
+                          <a:cs typeface="Meiryo" pitchFamily="34" charset="-120"/>
+                        </a:rPr>
+                        <a:t>単体テストのシナリオ</a:t>
+                      </a:r>
+                      <a:endParaRPr lang="en-US" sz="1000" dirty="0">
+                        <a:latin typeface="Meiryo" charset="0"/>
+                        <a:ea typeface="Meiryo" charset="0"/>
+                        <a:cs typeface="Meiryo" charset="0"/>
+                      </a:endParaRPr>
+                    </a:p>
+                  </a:txBody>
+                  <a:tcPr marL="45720" marR="45720" marT="45720" marB="45720" anchor="ctr">
+                    <a:lnL w="6350" cap="flat" cmpd="sng" algn="ctr">
+                      <a:solidFill>
+                        <a:srgbClr val="C9D6D8"/>
+                      </a:solidFill>
+                      <a:prstDash val="solid"/>
+                      <a:round/>
+                      <a:headEnd type="none" w="med" len="med"/>
+                      <a:tailEnd type="none" w="med" len="med"/>
+                    </a:lnL>
+                    <a:lnR w="6350" cap="flat" cmpd="sng" algn="ctr">
+                      <a:solidFill>
+                        <a:srgbClr val="C9D6D8"/>
+                      </a:solidFill>
+                      <a:prstDash val="solid"/>
+                      <a:round/>
+                      <a:headEnd type="none" w="med" len="med"/>
+                      <a:tailEnd type="none" w="med" len="med"/>
+                    </a:lnR>
+                    <a:lnT w="6350" cap="flat" cmpd="sng" algn="ctr">
+                      <a:solidFill>
+                        <a:srgbClr val="C9D6D8"/>
+                      </a:solidFill>
+                      <a:prstDash val="solid"/>
+                      <a:round/>
+                      <a:headEnd type="none" w="med" len="med"/>
+                      <a:tailEnd type="none" w="med" len="med"/>
+                    </a:lnT>
+                    <a:lnB w="6350" cap="flat" cmpd="sng" algn="ctr">
+                      <a:solidFill>
+                        <a:srgbClr val="C9D6D8"/>
+                      </a:solidFill>
+                      <a:prstDash val="solid"/>
+                      <a:round/>
+                      <a:headEnd type="none" w="med" len="med"/>
+                      <a:tailEnd type="none" w="med" len="med"/>
+                    </a:lnB>
+                    <a:solidFill>
+                      <a:srgbClr val="0F2A33"/>
+                    </a:solidFill>
+                  </a:tcPr>
+                </a:tc>
+                <a:tc>
+                  <a:txBody>
+                    <a:bodyPr/>
+                    <a:lstStyle/>
+                    <a:p>
+                      <a:pPr indent="0" marL="0">
+                        <a:buNone/>
+                      </a:pPr>
+                      <a:r>
+                        <a:rPr lang="en-US" sz="1000" b="1" dirty="0">
+                          <a:solidFill>
+                            <a:srgbClr val="FFFFFF"/>
+                          </a:solidFill>
+                          <a:latin typeface="Meiryo" pitchFamily="34" charset="0"/>
+                          <a:ea typeface="Meiryo" pitchFamily="34" charset="-122"/>
+                          <a:cs typeface="Meiryo" pitchFamily="34" charset="-120"/>
+                        </a:rPr>
+                        <a:t>期待結果</a:t>
+                      </a:r>
+                      <a:endParaRPr lang="en-US" sz="1000" dirty="0">
+                        <a:latin typeface="Meiryo" charset="0"/>
+                        <a:ea typeface="Meiryo" charset="0"/>
+                        <a:cs typeface="Meiryo" charset="0"/>
+                      </a:endParaRPr>
+                    </a:p>
+                  </a:txBody>
+                  <a:tcPr marL="45720" marR="45720" marT="45720" marB="45720" anchor="ctr">
+                    <a:lnL w="6350" cap="flat" cmpd="sng" algn="ctr">
+                      <a:solidFill>
+                        <a:srgbClr val="C9D6D8"/>
+                      </a:solidFill>
+                      <a:prstDash val="solid"/>
+                      <a:round/>
+                      <a:headEnd type="none" w="med" len="med"/>
+                      <a:tailEnd type="none" w="med" len="med"/>
+                    </a:lnL>
+                    <a:lnR w="6350" cap="flat" cmpd="sng" algn="ctr">
+                      <a:solidFill>
+                        <a:srgbClr val="C9D6D8"/>
+                      </a:solidFill>
+                      <a:prstDash val="solid"/>
+                      <a:round/>
+                      <a:headEnd type="none" w="med" len="med"/>
+                      <a:tailEnd type="none" w="med" len="med"/>
+                    </a:lnR>
+                    <a:lnT w="6350" cap="flat" cmpd="sng" algn="ctr">
+                      <a:solidFill>
+                        <a:srgbClr val="C9D6D8"/>
+                      </a:solidFill>
+                      <a:prstDash val="solid"/>
+                      <a:round/>
+                      <a:headEnd type="none" w="med" len="med"/>
+                      <a:tailEnd type="none" w="med" len="med"/>
+                    </a:lnT>
+                    <a:lnB w="6350" cap="flat" cmpd="sng" algn="ctr">
+                      <a:solidFill>
+                        <a:srgbClr val="C9D6D8"/>
+                      </a:solidFill>
+                      <a:prstDash val="solid"/>
+                      <a:round/>
+                      <a:headEnd type="none" w="med" len="med"/>
+                      <a:tailEnd type="none" w="med" len="med"/>
+                    </a:lnB>
+                    <a:solidFill>
+                      <a:srgbClr val="0F2A33"/>
+                    </a:solidFill>
+                  </a:tcPr>
+                </a:tc>
+              </a:tr>
+              <a:tr h="347472">
+                <a:tc>
+                  <a:txBody>
+                    <a:bodyPr/>
+                    <a:lstStyle/>
+                    <a:p>
+                      <a:pPr indent="0" marL="0">
+                        <a:buNone/>
+                      </a:pPr>
+                      <a:r>
+                        <a:rPr lang="en-US" sz="1000" dirty="0">
+                          <a:solidFill>
+                            <a:srgbClr val="1B2B30"/>
+                          </a:solidFill>
+                          <a:latin typeface="Meiryo" pitchFamily="34" charset="0"/>
+                          <a:ea typeface="Meiryo" pitchFamily="34" charset="-122"/>
+                          <a:cs typeface="Meiryo" pitchFamily="34" charset="-120"/>
+                        </a:rPr>
+                        <a:t>立ったまま・歩行</a:t>
+                      </a:r>
+                      <a:endParaRPr lang="en-US" sz="1000" dirty="0">
+                        <a:latin typeface="Meiryo" charset="0"/>
+                        <a:ea typeface="Meiryo" charset="0"/>
+                        <a:cs typeface="Meiryo" charset="0"/>
+                      </a:endParaRPr>
+                    </a:p>
+                  </a:txBody>
+                  <a:tcPr marL="45720" marR="45720" marT="45720" marB="45720" anchor="ctr">
+                    <a:lnL w="6350" cap="flat" cmpd="sng" algn="ctr">
+                      <a:solidFill>
+                        <a:srgbClr val="C9D6D8"/>
+                      </a:solidFill>
+                      <a:prstDash val="solid"/>
+                      <a:round/>
+                      <a:headEnd type="none" w="med" len="med"/>
+                      <a:tailEnd type="none" w="med" len="med"/>
+                    </a:lnL>
+                    <a:lnR w="6350" cap="flat" cmpd="sng" algn="ctr">
+                      <a:solidFill>
+                        <a:srgbClr val="C9D6D8"/>
+                      </a:solidFill>
+                      <a:prstDash val="solid"/>
+                      <a:round/>
+                      <a:headEnd type="none" w="med" len="med"/>
+                      <a:tailEnd type="none" w="med" len="med"/>
+                    </a:lnR>
+                    <a:lnT w="6350" cap="flat" cmpd="sng" algn="ctr">
+                      <a:solidFill>
+                        <a:srgbClr val="C9D6D8"/>
+                      </a:solidFill>
+                      <a:prstDash val="solid"/>
+                      <a:round/>
+                      <a:headEnd type="none" w="med" len="med"/>
+                      <a:tailEnd type="none" w="med" len="med"/>
+                    </a:lnT>
+                    <a:lnB w="6350" cap="flat" cmpd="sng" algn="ctr">
+                      <a:solidFill>
+                        <a:srgbClr val="C9D6D8"/>
+                      </a:solidFill>
+                      <a:prstDash val="solid"/>
+                      <a:round/>
+                      <a:headEnd type="none" w="med" len="med"/>
+                      <a:tailEnd type="none" w="med" len="med"/>
+                    </a:lnB>
+                  </a:tcPr>
+                </a:tc>
+                <a:tc>
+                  <a:txBody>
+                    <a:bodyPr/>
+                    <a:lstStyle/>
+                    <a:p>
+                      <a:pPr indent="0" marL="0">
+                        <a:buNone/>
+                      </a:pPr>
+                      <a:r>
+                        <a:rPr lang="en-US" sz="1000" dirty="0">
+                          <a:solidFill>
+                            <a:srgbClr val="1B2B30"/>
+                          </a:solidFill>
+                          <a:latin typeface="Meiryo" pitchFamily="34" charset="0"/>
+                          <a:ea typeface="Meiryo" pitchFamily="34" charset="-122"/>
+                          <a:cs typeface="Meiryo" pitchFamily="34" charset="-120"/>
+                        </a:rPr>
+                        <a:t>何も起きない</a:t>
+                      </a:r>
+                      <a:endParaRPr lang="en-US" sz="1000" dirty="0">
+                        <a:latin typeface="Meiryo" charset="0"/>
+                        <a:ea typeface="Meiryo" charset="0"/>
+                        <a:cs typeface="Meiryo" charset="0"/>
+                      </a:endParaRPr>
+                    </a:p>
+                  </a:txBody>
+                  <a:tcPr marL="45720" marR="45720" marT="45720" marB="45720" anchor="ctr">
+                    <a:lnL w="6350" cap="flat" cmpd="sng" algn="ctr">
+                      <a:solidFill>
+                        <a:srgbClr val="C9D6D8"/>
+                      </a:solidFill>
+                      <a:prstDash val="solid"/>
+                      <a:round/>
+                      <a:headEnd type="none" w="med" len="med"/>
+                      <a:tailEnd type="none" w="med" len="med"/>
+                    </a:lnL>
+                    <a:lnR w="6350" cap="flat" cmpd="sng" algn="ctr">
+                      <a:solidFill>
+                        <a:srgbClr val="C9D6D8"/>
+                      </a:solidFill>
+                      <a:prstDash val="solid"/>
+                      <a:round/>
+                      <a:headEnd type="none" w="med" len="med"/>
+                      <a:tailEnd type="none" w="med" len="med"/>
+                    </a:lnR>
+                    <a:lnT w="6350" cap="flat" cmpd="sng" algn="ctr">
+                      <a:solidFill>
+                        <a:srgbClr val="C9D6D8"/>
+                      </a:solidFill>
+                      <a:prstDash val="solid"/>
+                      <a:round/>
+                      <a:headEnd type="none" w="med" len="med"/>
+                      <a:tailEnd type="none" w="med" len="med"/>
+                    </a:lnT>
+                    <a:lnB w="6350" cap="flat" cmpd="sng" algn="ctr">
+                      <a:solidFill>
+                        <a:srgbClr val="C9D6D8"/>
+                      </a:solidFill>
+                      <a:prstDash val="solid"/>
+                      <a:round/>
+                      <a:headEnd type="none" w="med" len="med"/>
+                      <a:tailEnd type="none" w="med" len="med"/>
+                    </a:lnB>
+                  </a:tcPr>
+                </a:tc>
+                <a:tc>
+                  <a:txBody>
+                    <a:bodyPr/>
+                    <a:lstStyle/>
+                    <a:p>
+                      <a:pPr indent="0" marL="0">
+                        <a:buNone/>
+                      </a:pPr>
+                      <a:r>
+                        <a:rPr lang="en-US" sz="1000" dirty="0">
+                          <a:solidFill>
+                            <a:srgbClr val="1B2B30"/>
+                          </a:solidFill>
+                          <a:latin typeface="Meiryo" pitchFamily="34" charset="0"/>
+                          <a:ea typeface="Meiryo" pitchFamily="34" charset="-122"/>
+                          <a:cs typeface="Meiryo" pitchFamily="34" charset="-120"/>
+                        </a:rPr>
+                        <a:t>0.5秒で倒れてそのまま</a:t>
+                      </a:r>
+                      <a:endParaRPr lang="en-US" sz="1000" dirty="0">
+                        <a:latin typeface="Meiryo" charset="0"/>
+                        <a:ea typeface="Meiryo" charset="0"/>
+                        <a:cs typeface="Meiryo" charset="0"/>
+                      </a:endParaRPr>
+                    </a:p>
+                  </a:txBody>
+                  <a:tcPr marL="45720" marR="45720" marT="45720" marB="45720" anchor="ctr">
+                    <a:lnL w="6350" cap="flat" cmpd="sng" algn="ctr">
+                      <a:solidFill>
+                        <a:srgbClr val="C9D6D8"/>
+                      </a:solidFill>
+                      <a:prstDash val="solid"/>
+                      <a:round/>
+                      <a:headEnd type="none" w="med" len="med"/>
+                      <a:tailEnd type="none" w="med" len="med"/>
+                    </a:lnL>
+                    <a:lnR w="6350" cap="flat" cmpd="sng" algn="ctr">
+                      <a:solidFill>
+                        <a:srgbClr val="C9D6D8"/>
+                      </a:solidFill>
+                      <a:prstDash val="solid"/>
+                      <a:round/>
+                      <a:headEnd type="none" w="med" len="med"/>
+                      <a:tailEnd type="none" w="med" len="med"/>
+                    </a:lnR>
+                    <a:lnT w="6350" cap="flat" cmpd="sng" algn="ctr">
+                      <a:solidFill>
+                        <a:srgbClr val="C9D6D8"/>
+                      </a:solidFill>
+                      <a:prstDash val="solid"/>
+                      <a:round/>
+                      <a:headEnd type="none" w="med" len="med"/>
+                      <a:tailEnd type="none" w="med" len="med"/>
+                    </a:lnT>
+                    <a:lnB w="6350" cap="flat" cmpd="sng" algn="ctr">
+                      <a:solidFill>
+                        <a:srgbClr val="C9D6D8"/>
+                      </a:solidFill>
+                      <a:prstDash val="solid"/>
+                      <a:round/>
+                      <a:headEnd type="none" w="med" len="med"/>
+                      <a:tailEnd type="none" w="med" len="med"/>
+                    </a:lnB>
+                  </a:tcPr>
+                </a:tc>
+                <a:tc>
+                  <a:txBody>
+                    <a:bodyPr/>
+                    <a:lstStyle/>
+                    <a:p>
+                      <a:pPr indent="0" marL="0">
+                        <a:buNone/>
+                      </a:pPr>
+                      <a:r>
+                        <a:rPr lang="en-US" sz="1000" dirty="0">
+                          <a:solidFill>
+                            <a:srgbClr val="1B2B30"/>
+                          </a:solidFill>
+                          <a:latin typeface="Meiryo" pitchFamily="34" charset="0"/>
+                          <a:ea typeface="Meiryo" pitchFamily="34" charset="-122"/>
+                          <a:cs typeface="Meiryo" pitchFamily="34" charset="-120"/>
+                        </a:rPr>
+                        <a:t>約3秒後に1回だけ確定</a:t>
+                      </a:r>
+                      <a:endParaRPr lang="en-US" sz="1000" dirty="0">
+                        <a:latin typeface="Meiryo" charset="0"/>
+                        <a:ea typeface="Meiryo" charset="0"/>
+                        <a:cs typeface="Meiryo" charset="0"/>
+                      </a:endParaRPr>
+                    </a:p>
+                  </a:txBody>
+                  <a:tcPr marL="45720" marR="45720" marT="45720" marB="45720" anchor="ctr">
+                    <a:lnL w="6350" cap="flat" cmpd="sng" algn="ctr">
+                      <a:solidFill>
+                        <a:srgbClr val="C9D6D8"/>
+                      </a:solidFill>
+                      <a:prstDash val="solid"/>
+                      <a:round/>
+                      <a:headEnd type="none" w="med" len="med"/>
+                      <a:tailEnd type="none" w="med" len="med"/>
+                    </a:lnL>
+                    <a:lnR w="6350" cap="flat" cmpd="sng" algn="ctr">
+                      <a:solidFill>
+                        <a:srgbClr val="C9D6D8"/>
+                      </a:solidFill>
+                      <a:prstDash val="solid"/>
+                      <a:round/>
+                      <a:headEnd type="none" w="med" len="med"/>
+                      <a:tailEnd type="none" w="med" len="med"/>
+                    </a:lnR>
+                    <a:lnT w="6350" cap="flat" cmpd="sng" algn="ctr">
+                      <a:solidFill>
+                        <a:srgbClr val="C9D6D8"/>
+                      </a:solidFill>
+                      <a:prstDash val="solid"/>
+                      <a:round/>
+                      <a:headEnd type="none" w="med" len="med"/>
+                      <a:tailEnd type="none" w="med" len="med"/>
+                    </a:lnT>
+                    <a:lnB w="6350" cap="flat" cmpd="sng" algn="ctr">
+                      <a:solidFill>
+                        <a:srgbClr val="C9D6D8"/>
+                      </a:solidFill>
+                      <a:prstDash val="solid"/>
+                      <a:round/>
+                      <a:headEnd type="none" w="med" len="med"/>
+                      <a:tailEnd type="none" w="med" len="med"/>
+                    </a:lnB>
+                  </a:tcPr>
+                </a:tc>
+              </a:tr>
+              <a:tr h="347472">
+                <a:tc>
+                  <a:txBody>
+                    <a:bodyPr/>
+                    <a:lstStyle/>
+                    <a:p>
+                      <a:pPr indent="0" marL="0">
+                        <a:buNone/>
+                      </a:pPr>
+                      <a:r>
+                        <a:rPr lang="en-US" sz="1000" dirty="0">
+                          <a:solidFill>
+                            <a:srgbClr val="1B2B30"/>
+                          </a:solidFill>
+                          <a:latin typeface="Meiryo" pitchFamily="34" charset="0"/>
+                          <a:ea typeface="Meiryo" pitchFamily="34" charset="-122"/>
+                          <a:cs typeface="Meiryo" pitchFamily="34" charset="-120"/>
+                        </a:rPr>
+                        <a:t>3秒かけてゆっくり座る</a:t>
+                      </a:r>
+                      <a:endParaRPr lang="en-US" sz="1000" dirty="0">
+                        <a:latin typeface="Meiryo" charset="0"/>
+                        <a:ea typeface="Meiryo" charset="0"/>
+                        <a:cs typeface="Meiryo" charset="0"/>
+                      </a:endParaRPr>
+                    </a:p>
+                  </a:txBody>
+                  <a:tcPr marL="45720" marR="45720" marT="45720" marB="45720" anchor="ctr">
+                    <a:lnL w="6350" cap="flat" cmpd="sng" algn="ctr">
+                      <a:solidFill>
+                        <a:srgbClr val="C9D6D8"/>
+                      </a:solidFill>
+                      <a:prstDash val="solid"/>
+                      <a:round/>
+                      <a:headEnd type="none" w="med" len="med"/>
+                      <a:tailEnd type="none" w="med" len="med"/>
+                    </a:lnL>
+                    <a:lnR w="6350" cap="flat" cmpd="sng" algn="ctr">
+                      <a:solidFill>
+                        <a:srgbClr val="C9D6D8"/>
+                      </a:solidFill>
+                      <a:prstDash val="solid"/>
+                      <a:round/>
+                      <a:headEnd type="none" w="med" len="med"/>
+                      <a:tailEnd type="none" w="med" len="med"/>
+                    </a:lnR>
+                    <a:lnT w="6350" cap="flat" cmpd="sng" algn="ctr">
+                      <a:solidFill>
+                        <a:srgbClr val="C9D6D8"/>
+                      </a:solidFill>
+                      <a:prstDash val="solid"/>
+                      <a:round/>
+                      <a:headEnd type="none" w="med" len="med"/>
+                      <a:tailEnd type="none" w="med" len="med"/>
+                    </a:lnT>
+                    <a:lnB w="6350" cap="flat" cmpd="sng" algn="ctr">
+                      <a:solidFill>
+                        <a:srgbClr val="C9D6D8"/>
+                      </a:solidFill>
+                      <a:prstDash val="solid"/>
+                      <a:round/>
+                      <a:headEnd type="none" w="med" len="med"/>
+                      <a:tailEnd type="none" w="med" len="med"/>
+                    </a:lnB>
+                  </a:tcPr>
+                </a:tc>
+                <a:tc>
+                  <a:txBody>
+                    <a:bodyPr/>
+                    <a:lstStyle/>
+                    <a:p>
+                      <a:pPr indent="0" marL="0">
+                        <a:buNone/>
+                      </a:pPr>
+                      <a:r>
+                        <a:rPr lang="en-US" sz="1000" dirty="0">
+                          <a:solidFill>
+                            <a:srgbClr val="1B2B30"/>
+                          </a:solidFill>
+                          <a:latin typeface="Meiryo" pitchFamily="34" charset="0"/>
+                          <a:ea typeface="Meiryo" pitchFamily="34" charset="-122"/>
+                          <a:cs typeface="Meiryo" pitchFamily="34" charset="-120"/>
+                        </a:rPr>
+                        <a:t>転倒と判定しない</a:t>
+                      </a:r>
+                      <a:endParaRPr lang="en-US" sz="1000" dirty="0">
+                        <a:latin typeface="Meiryo" charset="0"/>
+                        <a:ea typeface="Meiryo" charset="0"/>
+                        <a:cs typeface="Meiryo" charset="0"/>
+                      </a:endParaRPr>
+                    </a:p>
+                  </a:txBody>
+                  <a:tcPr marL="45720" marR="45720" marT="45720" marB="45720" anchor="ctr">
+                    <a:lnL w="6350" cap="flat" cmpd="sng" algn="ctr">
+                      <a:solidFill>
+                        <a:srgbClr val="C9D6D8"/>
+                      </a:solidFill>
+                      <a:prstDash val="solid"/>
+                      <a:round/>
+                      <a:headEnd type="none" w="med" len="med"/>
+                      <a:tailEnd type="none" w="med" len="med"/>
+                    </a:lnL>
+                    <a:lnR w="6350" cap="flat" cmpd="sng" algn="ctr">
+                      <a:solidFill>
+                        <a:srgbClr val="C9D6D8"/>
+                      </a:solidFill>
+                      <a:prstDash val="solid"/>
+                      <a:round/>
+                      <a:headEnd type="none" w="med" len="med"/>
+                      <a:tailEnd type="none" w="med" len="med"/>
+                    </a:lnR>
+                    <a:lnT w="6350" cap="flat" cmpd="sng" algn="ctr">
+                      <a:solidFill>
+                        <a:srgbClr val="C9D6D8"/>
+                      </a:solidFill>
+                      <a:prstDash val="solid"/>
+                      <a:round/>
+                      <a:headEnd type="none" w="med" len="med"/>
+                      <a:tailEnd type="none" w="med" len="med"/>
+                    </a:lnT>
+                    <a:lnB w="6350" cap="flat" cmpd="sng" algn="ctr">
+                      <a:solidFill>
+                        <a:srgbClr val="C9D6D8"/>
+                      </a:solidFill>
+                      <a:prstDash val="solid"/>
+                      <a:round/>
+                      <a:headEnd type="none" w="med" len="med"/>
+                      <a:tailEnd type="none" w="med" len="med"/>
+                    </a:lnB>
+                  </a:tcPr>
+                </a:tc>
+                <a:tc>
+                  <a:txBody>
+                    <a:bodyPr/>
+                    <a:lstStyle/>
+                    <a:p>
+                      <a:pPr indent="0" marL="0">
+                        <a:buNone/>
+                      </a:pPr>
+                      <a:r>
+                        <a:rPr lang="en-US" sz="1000" dirty="0">
+                          <a:solidFill>
+                            <a:srgbClr val="1B2B30"/>
+                          </a:solidFill>
+                          <a:latin typeface="Meiryo" pitchFamily="34" charset="0"/>
+                          <a:ea typeface="Meiryo" pitchFamily="34" charset="-122"/>
+                          <a:cs typeface="Meiryo" pitchFamily="34" charset="-120"/>
+                        </a:rPr>
+                        <a:t>倒れた後に顔が見えない</a:t>
+                      </a:r>
+                      <a:endParaRPr lang="en-US" sz="1000" dirty="0">
+                        <a:latin typeface="Meiryo" charset="0"/>
+                        <a:ea typeface="Meiryo" charset="0"/>
+                        <a:cs typeface="Meiryo" charset="0"/>
+                      </a:endParaRPr>
+                    </a:p>
+                  </a:txBody>
+                  <a:tcPr marL="45720" marR="45720" marT="45720" marB="45720" anchor="ctr">
+                    <a:lnL w="6350" cap="flat" cmpd="sng" algn="ctr">
+                      <a:solidFill>
+                        <a:srgbClr val="C9D6D8"/>
+                      </a:solidFill>
+                      <a:prstDash val="solid"/>
+                      <a:round/>
+                      <a:headEnd type="none" w="med" len="med"/>
+                      <a:tailEnd type="none" w="med" len="med"/>
+                    </a:lnL>
+                    <a:lnR w="6350" cap="flat" cmpd="sng" algn="ctr">
+                      <a:solidFill>
+                        <a:srgbClr val="C9D6D8"/>
+                      </a:solidFill>
+                      <a:prstDash val="solid"/>
+                      <a:round/>
+                      <a:headEnd type="none" w="med" len="med"/>
+                      <a:tailEnd type="none" w="med" len="med"/>
+                    </a:lnR>
+                    <a:lnT w="6350" cap="flat" cmpd="sng" algn="ctr">
+                      <a:solidFill>
+                        <a:srgbClr val="C9D6D8"/>
+                      </a:solidFill>
+                      <a:prstDash val="solid"/>
+                      <a:round/>
+                      <a:headEnd type="none" w="med" len="med"/>
+                      <a:tailEnd type="none" w="med" len="med"/>
+                    </a:lnT>
+                    <a:lnB w="6350" cap="flat" cmpd="sng" algn="ctr">
+                      <a:solidFill>
+                        <a:srgbClr val="C9D6D8"/>
+                      </a:solidFill>
+                      <a:prstDash val="solid"/>
+                      <a:round/>
+                      <a:headEnd type="none" w="med" len="med"/>
+                      <a:tailEnd type="none" w="med" len="med"/>
+                    </a:lnB>
+                  </a:tcPr>
+                </a:tc>
+                <a:tc>
+                  <a:txBody>
+                    <a:bodyPr/>
+                    <a:lstStyle/>
+                    <a:p>
+                      <a:pPr indent="0" marL="0">
+                        <a:buNone/>
+                      </a:pPr>
+                      <a:r>
+                        <a:rPr lang="en-US" sz="1000" dirty="0">
+                          <a:solidFill>
+                            <a:srgbClr val="1B2B30"/>
+                          </a:solidFill>
+                          <a:latin typeface="Meiryo" pitchFamily="34" charset="0"/>
+                          <a:ea typeface="Meiryo" pitchFamily="34" charset="-122"/>
+                          <a:cs typeface="Meiryo" pitchFamily="34" charset="-120"/>
+                        </a:rPr>
+                        <a:t>確定を維持</a:t>
+                      </a:r>
+                      <a:endParaRPr lang="en-US" sz="1000" dirty="0">
+                        <a:latin typeface="Meiryo" charset="0"/>
+                        <a:ea typeface="Meiryo" charset="0"/>
+                        <a:cs typeface="Meiryo" charset="0"/>
+                      </a:endParaRPr>
+                    </a:p>
+                  </a:txBody>
+                  <a:tcPr marL="45720" marR="45720" marT="45720" marB="45720" anchor="ctr">
+                    <a:lnL w="6350" cap="flat" cmpd="sng" algn="ctr">
+                      <a:solidFill>
+                        <a:srgbClr val="C9D6D8"/>
+                      </a:solidFill>
+                      <a:prstDash val="solid"/>
+                      <a:round/>
+                      <a:headEnd type="none" w="med" len="med"/>
+                      <a:tailEnd type="none" w="med" len="med"/>
+                    </a:lnL>
+                    <a:lnR w="6350" cap="flat" cmpd="sng" algn="ctr">
+                      <a:solidFill>
+                        <a:srgbClr val="C9D6D8"/>
+                      </a:solidFill>
+                      <a:prstDash val="solid"/>
+                      <a:round/>
+                      <a:headEnd type="none" w="med" len="med"/>
+                      <a:tailEnd type="none" w="med" len="med"/>
+                    </a:lnR>
+                    <a:lnT w="6350" cap="flat" cmpd="sng" algn="ctr">
+                      <a:solidFill>
+                        <a:srgbClr val="C9D6D8"/>
+                      </a:solidFill>
+                      <a:prstDash val="solid"/>
+                      <a:round/>
+                      <a:headEnd type="none" w="med" len="med"/>
+                      <a:tailEnd type="none" w="med" len="med"/>
+                    </a:lnT>
+                    <a:lnB w="6350" cap="flat" cmpd="sng" algn="ctr">
+                      <a:solidFill>
+                        <a:srgbClr val="C9D6D8"/>
+                      </a:solidFill>
+                      <a:prstDash val="solid"/>
+                      <a:round/>
+                      <a:headEnd type="none" w="med" len="med"/>
+                      <a:tailEnd type="none" w="med" len="med"/>
+                    </a:lnB>
+                  </a:tcPr>
+                </a:tc>
+              </a:tr>
+              <a:tr h="347472">
+                <a:tc>
+                  <a:txBody>
+                    <a:bodyPr/>
+                    <a:lstStyle/>
+                    <a:p>
+                      <a:pPr indent="0" marL="0">
+                        <a:buNone/>
+                      </a:pPr>
+                      <a:r>
+                        <a:rPr lang="en-US" sz="1000" dirty="0">
+                          <a:solidFill>
+                            <a:srgbClr val="1B2B30"/>
+                          </a:solidFill>
+                          <a:latin typeface="Meiryo" pitchFamily="34" charset="0"/>
+                          <a:ea typeface="Meiryo" pitchFamily="34" charset="-122"/>
+                          <a:cs typeface="Meiryo" pitchFamily="34" charset="-120"/>
+                        </a:rPr>
+                        <a:t>素早くしゃがんで立つ</a:t>
+                      </a:r>
+                      <a:endParaRPr lang="en-US" sz="1000" dirty="0">
+                        <a:latin typeface="Meiryo" charset="0"/>
+                        <a:ea typeface="Meiryo" charset="0"/>
+                        <a:cs typeface="Meiryo" charset="0"/>
+                      </a:endParaRPr>
+                    </a:p>
+                  </a:txBody>
+                  <a:tcPr marL="45720" marR="45720" marT="45720" marB="45720" anchor="ctr">
+                    <a:lnL w="6350" cap="flat" cmpd="sng" algn="ctr">
+                      <a:solidFill>
+                        <a:srgbClr val="C9D6D8"/>
+                      </a:solidFill>
+                      <a:prstDash val="solid"/>
+                      <a:round/>
+                      <a:headEnd type="none" w="med" len="med"/>
+                      <a:tailEnd type="none" w="med" len="med"/>
+                    </a:lnL>
+                    <a:lnR w="6350" cap="flat" cmpd="sng" algn="ctr">
+                      <a:solidFill>
+                        <a:srgbClr val="C9D6D8"/>
+                      </a:solidFill>
+                      <a:prstDash val="solid"/>
+                      <a:round/>
+                      <a:headEnd type="none" w="med" len="med"/>
+                      <a:tailEnd type="none" w="med" len="med"/>
+                    </a:lnR>
+                    <a:lnT w="6350" cap="flat" cmpd="sng" algn="ctr">
+                      <a:solidFill>
+                        <a:srgbClr val="C9D6D8"/>
+                      </a:solidFill>
+                      <a:prstDash val="solid"/>
+                      <a:round/>
+                      <a:headEnd type="none" w="med" len="med"/>
+                      <a:tailEnd type="none" w="med" len="med"/>
+                    </a:lnT>
+                    <a:lnB w="6350" cap="flat" cmpd="sng" algn="ctr">
+                      <a:solidFill>
+                        <a:srgbClr val="C9D6D8"/>
+                      </a:solidFill>
+                      <a:prstDash val="solid"/>
+                      <a:round/>
+                      <a:headEnd type="none" w="med" len="med"/>
+                      <a:tailEnd type="none" w="med" len="med"/>
+                    </a:lnB>
+                  </a:tcPr>
+                </a:tc>
+                <a:tc>
+                  <a:txBody>
+                    <a:bodyPr/>
+                    <a:lstStyle/>
+                    <a:p>
+                      <a:pPr indent="0" marL="0">
+                        <a:buNone/>
+                      </a:pPr>
+                      <a:r>
+                        <a:rPr lang="en-US" sz="1000" dirty="0">
+                          <a:solidFill>
+                            <a:srgbClr val="1B2B30"/>
+                          </a:solidFill>
+                          <a:latin typeface="Meiryo" pitchFamily="34" charset="0"/>
+                          <a:ea typeface="Meiryo" pitchFamily="34" charset="-122"/>
+                          <a:cs typeface="Meiryo" pitchFamily="34" charset="-120"/>
+                        </a:rPr>
+                        <a:t>疑い→取り消し</a:t>
+                      </a:r>
+                      <a:endParaRPr lang="en-US" sz="1000" dirty="0">
+                        <a:latin typeface="Meiryo" charset="0"/>
+                        <a:ea typeface="Meiryo" charset="0"/>
+                        <a:cs typeface="Meiryo" charset="0"/>
+                      </a:endParaRPr>
+                    </a:p>
+                  </a:txBody>
+                  <a:tcPr marL="45720" marR="45720" marT="45720" marB="45720" anchor="ctr">
+                    <a:lnL w="6350" cap="flat" cmpd="sng" algn="ctr">
+                      <a:solidFill>
+                        <a:srgbClr val="C9D6D8"/>
+                      </a:solidFill>
+                      <a:prstDash val="solid"/>
+                      <a:round/>
+                      <a:headEnd type="none" w="med" len="med"/>
+                      <a:tailEnd type="none" w="med" len="med"/>
+                    </a:lnL>
+                    <a:lnR w="6350" cap="flat" cmpd="sng" algn="ctr">
+                      <a:solidFill>
+                        <a:srgbClr val="C9D6D8"/>
+                      </a:solidFill>
+                      <a:prstDash val="solid"/>
+                      <a:round/>
+                      <a:headEnd type="none" w="med" len="med"/>
+                      <a:tailEnd type="none" w="med" len="med"/>
+                    </a:lnR>
+                    <a:lnT w="6350" cap="flat" cmpd="sng" algn="ctr">
+                      <a:solidFill>
+                        <a:srgbClr val="C9D6D8"/>
+                      </a:solidFill>
+                      <a:prstDash val="solid"/>
+                      <a:round/>
+                      <a:headEnd type="none" w="med" len="med"/>
+                      <a:tailEnd type="none" w="med" len="med"/>
+                    </a:lnT>
+                    <a:lnB w="6350" cap="flat" cmpd="sng" algn="ctr">
+                      <a:solidFill>
+                        <a:srgbClr val="C9D6D8"/>
+                      </a:solidFill>
+                      <a:prstDash val="solid"/>
+                      <a:round/>
+                      <a:headEnd type="none" w="med" len="med"/>
+                      <a:tailEnd type="none" w="med" len="med"/>
+                    </a:lnB>
+                  </a:tcPr>
+                </a:tc>
+                <a:tc>
+                  <a:txBody>
+                    <a:bodyPr/>
+                    <a:lstStyle/>
+                    <a:p>
+                      <a:pPr indent="0" marL="0">
+                        <a:buNone/>
+                      </a:pPr>
+                      <a:r>
+                        <a:rPr lang="en-US" sz="1000" dirty="0">
+                          <a:solidFill>
+                            <a:srgbClr val="1B2B30"/>
+                          </a:solidFill>
+                          <a:latin typeface="Meiryo" pitchFamily="34" charset="0"/>
+                          <a:ea typeface="Meiryo" pitchFamily="34" charset="-122"/>
+                          <a:cs typeface="Meiryo" pitchFamily="34" charset="-120"/>
+                        </a:rPr>
+                        <a:t>起き上がって1秒</a:t>
+                      </a:r>
+                      <a:endParaRPr lang="en-US" sz="1000" dirty="0">
+                        <a:latin typeface="Meiryo" charset="0"/>
+                        <a:ea typeface="Meiryo" charset="0"/>
+                        <a:cs typeface="Meiryo" charset="0"/>
+                      </a:endParaRPr>
+                    </a:p>
+                  </a:txBody>
+                  <a:tcPr marL="45720" marR="45720" marT="45720" marB="45720" anchor="ctr">
+                    <a:lnL w="6350" cap="flat" cmpd="sng" algn="ctr">
+                      <a:solidFill>
+                        <a:srgbClr val="C9D6D8"/>
+                      </a:solidFill>
+                      <a:prstDash val="solid"/>
+                      <a:round/>
+                      <a:headEnd type="none" w="med" len="med"/>
+                      <a:tailEnd type="none" w="med" len="med"/>
+                    </a:lnL>
+                    <a:lnR w="6350" cap="flat" cmpd="sng" algn="ctr">
+                      <a:solidFill>
+                        <a:srgbClr val="C9D6D8"/>
+                      </a:solidFill>
+                      <a:prstDash val="solid"/>
+                      <a:round/>
+                      <a:headEnd type="none" w="med" len="med"/>
+                      <a:tailEnd type="none" w="med" len="med"/>
+                    </a:lnR>
+                    <a:lnT w="6350" cap="flat" cmpd="sng" algn="ctr">
+                      <a:solidFill>
+                        <a:srgbClr val="C9D6D8"/>
+                      </a:solidFill>
+                      <a:prstDash val="solid"/>
+                      <a:round/>
+                      <a:headEnd type="none" w="med" len="med"/>
+                      <a:tailEnd type="none" w="med" len="med"/>
+                    </a:lnT>
+                    <a:lnB w="6350" cap="flat" cmpd="sng" algn="ctr">
+                      <a:solidFill>
+                        <a:srgbClr val="C9D6D8"/>
+                      </a:solidFill>
+                      <a:prstDash val="solid"/>
+                      <a:round/>
+                      <a:headEnd type="none" w="med" len="med"/>
+                      <a:tailEnd type="none" w="med" len="med"/>
+                    </a:lnB>
+                  </a:tcPr>
+                </a:tc>
+                <a:tc>
+                  <a:txBody>
+                    <a:bodyPr/>
+                    <a:lstStyle/>
+                    <a:p>
+                      <a:pPr indent="0" marL="0">
+                        <a:buNone/>
+                      </a:pPr>
+                      <a:r>
+                        <a:rPr lang="en-US" sz="1000" dirty="0">
+                          <a:solidFill>
+                            <a:srgbClr val="1B2B30"/>
+                          </a:solidFill>
+                          <a:latin typeface="Meiryo" pitchFamily="34" charset="0"/>
+                          <a:ea typeface="Meiryo" pitchFamily="34" charset="-122"/>
+                          <a:cs typeface="Meiryo" pitchFamily="34" charset="-120"/>
+                        </a:rPr>
+                        <a:t>回復</a:t>
+                      </a:r>
+                      <a:endParaRPr lang="en-US" sz="1000" dirty="0">
+                        <a:latin typeface="Meiryo" charset="0"/>
+                        <a:ea typeface="Meiryo" charset="0"/>
+                        <a:cs typeface="Meiryo" charset="0"/>
+                      </a:endParaRPr>
+                    </a:p>
+                  </a:txBody>
+                  <a:tcPr marL="45720" marR="45720" marT="45720" marB="45720" anchor="ctr">
+                    <a:lnL w="6350" cap="flat" cmpd="sng" algn="ctr">
+                      <a:solidFill>
+                        <a:srgbClr val="C9D6D8"/>
+                      </a:solidFill>
+                      <a:prstDash val="solid"/>
+                      <a:round/>
+                      <a:headEnd type="none" w="med" len="med"/>
+                      <a:tailEnd type="none" w="med" len="med"/>
+                    </a:lnL>
+                    <a:lnR w="6350" cap="flat" cmpd="sng" algn="ctr">
+                      <a:solidFill>
+                        <a:srgbClr val="C9D6D8"/>
+                      </a:solidFill>
+                      <a:prstDash val="solid"/>
+                      <a:round/>
+                      <a:headEnd type="none" w="med" len="med"/>
+                      <a:tailEnd type="none" w="med" len="med"/>
+                    </a:lnR>
+                    <a:lnT w="6350" cap="flat" cmpd="sng" algn="ctr">
+                      <a:solidFill>
+                        <a:srgbClr val="C9D6D8"/>
+                      </a:solidFill>
+                      <a:prstDash val="solid"/>
+                      <a:round/>
+                      <a:headEnd type="none" w="med" len="med"/>
+                      <a:tailEnd type="none" w="med" len="med"/>
+                    </a:lnT>
+                    <a:lnB w="6350" cap="flat" cmpd="sng" algn="ctr">
+                      <a:solidFill>
+                        <a:srgbClr val="C9D6D8"/>
+                      </a:solidFill>
+                      <a:prstDash val="solid"/>
+                      <a:round/>
+                      <a:headEnd type="none" w="med" len="med"/>
+                      <a:tailEnd type="none" w="med" len="med"/>
+                    </a:lnB>
+                  </a:tcPr>
+                </a:tc>
+              </a:tr>
+            </a:tbl>
+          </a:graphicData>
+        </a:graphic>
+      </p:graphicFrame>
+      <p:sp>
+        <p:nvSpPr>
+          <p:cNvPr id="14" name="Text 11"/>
           <p:cNvSpPr txBox="1"/>
           <p:nvPr/>
         </p:nvSpPr>
@@ -4776,6 +5302,1176 @@
                 <a:ea typeface="Meiryo" pitchFamily="34" charset="-122"/>
                 <a:cs typeface="Meiryo" pitchFamily="34" charset="-120"/>
               </a:rPr>
+              <a:t>現在の状況と今後</a:t>
+            </a:r>
+            <a:endParaRPr lang="en-US" sz="2400" dirty="0"/>
+          </a:p>
+        </p:txBody>
+      </p:sp>
+      <p:sp>
+        <p:nvSpPr>
+          <p:cNvPr id="3" name="Text 1"/>
+          <p:cNvSpPr txBox="1"/>
+          <p:nvPr/>
+        </p:nvSpPr>
+        <p:spPr>
+          <a:xfrm>
+            <a:off x="457200" y="804672"/>
+            <a:ext cx="8229600" cy="320040"/>
+          </a:xfrm>
+          <a:prstGeom prst="rect">
+            <a:avLst/>
+          </a:prstGeom>
+          <a:noFill/>
+          <a:ln/>
+        </p:spPr>
+        <p:txBody>
+          <a:bodyPr wrap="square" lIns="0" tIns="0" rIns="0" bIns="0" rtlCol="0" anchor="ctr"/>
+          <a:lstStyle/>
+          <a:p>
+            <a:pPr indent="0" marL="0">
+              <a:buNone/>
+            </a:pPr>
+            <a:r>
+              <a:rPr lang="en-US" sz="1200" dirty="0">
+                <a:solidFill>
+                  <a:srgbClr val="5B6B70"/>
+                </a:solidFill>
+                <a:latin typeface="Meiryo" pitchFamily="34" charset="0"/>
+                <a:ea typeface="Meiryo" pitchFamily="34" charset="-122"/>
+                <a:cs typeface="Meiryo" pitchFamily="34" charset="-120"/>
+              </a:rPr>
+              <a:t>開発途中で貸与ボードの LCD が故障。事務局のご了承のもと、代替機到着後に更新版を提出</a:t>
+            </a:r>
+            <a:endParaRPr lang="en-US" sz="1200" dirty="0"/>
+          </a:p>
+        </p:txBody>
+      </p:sp>
+      <p:sp>
+        <p:nvSpPr>
+          <p:cNvPr id="4" name="Shape 2"/>
+          <p:cNvSpPr/>
+          <p:nvPr/>
+        </p:nvSpPr>
+        <p:spPr>
+          <a:xfrm>
+            <a:off x="457200" y="1371600"/>
+            <a:ext cx="411480" cy="411480"/>
+          </a:xfrm>
+          <a:prstGeom prst="ellipse">
+            <a:avLst/>
+          </a:prstGeom>
+          <a:solidFill>
+            <a:srgbClr val="3E9E6B"/>
+          </a:solidFill>
+          <a:ln w="12700">
+            <a:solidFill>
+              <a:srgbClr val="3E9E6B"/>
+            </a:solidFill>
+            <a:prstDash val="solid"/>
+          </a:ln>
+        </p:spPr>
+      </p:sp>
+      <p:pic>
+        <p:nvPicPr>
+          <p:cNvPr id="5" name="Image 0" descr="preencoded.png">    </p:cNvPr>
+          <p:cNvPicPr>
+            <a:picLocks noChangeAspect="1"/>
+          </p:cNvPicPr>
+          <p:nvPr/>
+        </p:nvPicPr>
+        <p:blipFill>
+          <a:blip r:embed="rId1"/>
+          <a:stretch>
+            <a:fillRect/>
+          </a:stretch>
+        </p:blipFill>
+        <p:spPr>
+          <a:xfrm>
+            <a:off x="547726" y="1462126"/>
+            <a:ext cx="230429" cy="230429"/>
+          </a:xfrm>
+          <a:prstGeom prst="rect">
+            <a:avLst/>
+          </a:prstGeom>
+        </p:spPr>
+      </p:pic>
+      <p:sp>
+        <p:nvSpPr>
+          <p:cNvPr id="6" name="Text 3"/>
+          <p:cNvSpPr txBox="1"/>
+          <p:nvPr/>
+        </p:nvSpPr>
+        <p:spPr>
+          <a:xfrm>
+            <a:off x="1005840" y="1371600"/>
+            <a:ext cx="4023360" cy="502920"/>
+          </a:xfrm>
+          <a:prstGeom prst="rect">
+            <a:avLst/>
+          </a:prstGeom>
+          <a:noFill/>
+          <a:ln/>
+        </p:spPr>
+        <p:txBody>
+          <a:bodyPr wrap="square" lIns="0" tIns="0" rIns="0" bIns="0" rtlCol="0" anchor="ctr"/>
+          <a:lstStyle/>
+          <a:p>
+            <a:pPr indent="0" marL="0">
+              <a:buNone/>
+            </a:pPr>
+            <a:r>
+              <a:rPr lang="en-US" sz="1050" dirty="0">
+                <a:solidFill>
+                  <a:srgbClr val="1B2B30"/>
+                </a:solidFill>
+                <a:latin typeface="Meiryo" pitchFamily="34" charset="0"/>
+                <a:ea typeface="Meiryo" pitchFamily="34" charset="-122"/>
+                <a:cs typeface="Meiryo" pitchFamily="34" charset="-120"/>
+              </a:rPr>
+              <a:t>μT-Kernel 3.0 起動・複数タスク・LED・シリアル出力（実機確認）</a:t>
+            </a:r>
+            <a:endParaRPr lang="en-US" sz="1050" dirty="0"/>
+          </a:p>
+        </p:txBody>
+      </p:sp>
+      <p:sp>
+        <p:nvSpPr>
+          <p:cNvPr id="7" name="Shape 4"/>
+          <p:cNvSpPr/>
+          <p:nvPr/>
+        </p:nvSpPr>
+        <p:spPr>
+          <a:xfrm>
+            <a:off x="457200" y="1975104"/>
+            <a:ext cx="411480" cy="411480"/>
+          </a:xfrm>
+          <a:prstGeom prst="ellipse">
+            <a:avLst/>
+          </a:prstGeom>
+          <a:solidFill>
+            <a:srgbClr val="3E9E6B"/>
+          </a:solidFill>
+          <a:ln w="12700">
+            <a:solidFill>
+              <a:srgbClr val="3E9E6B"/>
+            </a:solidFill>
+            <a:prstDash val="solid"/>
+          </a:ln>
+        </p:spPr>
+      </p:sp>
+      <p:pic>
+        <p:nvPicPr>
+          <p:cNvPr id="8" name="Image 1" descr="preencoded.png">    </p:cNvPr>
+          <p:cNvPicPr>
+            <a:picLocks noChangeAspect="1"/>
+          </p:cNvPicPr>
+          <p:nvPr/>
+        </p:nvPicPr>
+        <p:blipFill>
+          <a:blip r:embed="rId2"/>
+          <a:stretch>
+            <a:fillRect/>
+          </a:stretch>
+        </p:blipFill>
+        <p:spPr>
+          <a:xfrm>
+            <a:off x="547726" y="2065630"/>
+            <a:ext cx="230429" cy="230429"/>
+          </a:xfrm>
+          <a:prstGeom prst="rect">
+            <a:avLst/>
+          </a:prstGeom>
+        </p:spPr>
+      </p:pic>
+      <p:sp>
+        <p:nvSpPr>
+          <p:cNvPr id="9" name="Text 5"/>
+          <p:cNvSpPr txBox="1"/>
+          <p:nvPr/>
+        </p:nvSpPr>
+        <p:spPr>
+          <a:xfrm>
+            <a:off x="1005840" y="1975104"/>
+            <a:ext cx="4023360" cy="502920"/>
+          </a:xfrm>
+          <a:prstGeom prst="rect">
+            <a:avLst/>
+          </a:prstGeom>
+          <a:noFill/>
+          <a:ln/>
+        </p:spPr>
+        <p:txBody>
+          <a:bodyPr wrap="square" lIns="0" tIns="0" rIns="0" bIns="0" rtlCol="0" anchor="ctr"/>
+          <a:lstStyle/>
+          <a:p>
+            <a:pPr indent="0" marL="0">
+              <a:buNone/>
+            </a:pPr>
+            <a:r>
+              <a:rPr lang="en-US" sz="1050" dirty="0">
+                <a:solidFill>
+                  <a:srgbClr val="1B2B30"/>
+                </a:solidFill>
+                <a:latin typeface="Meiryo" pitchFamily="34" charset="0"/>
+                <a:ea typeface="Meiryo" pitchFamily="34" charset="-122"/>
+                <a:cs typeface="Meiryo" pitchFamily="34" charset="-120"/>
+              </a:rPr>
+              <a:t>公式 AI サンプルの実機動作（カメラ約30fps／推論約20回/秒）</a:t>
+            </a:r>
+            <a:endParaRPr lang="en-US" sz="1050" dirty="0"/>
+          </a:p>
+        </p:txBody>
+      </p:sp>
+      <p:sp>
+        <p:nvSpPr>
+          <p:cNvPr id="10" name="Shape 6"/>
+          <p:cNvSpPr/>
+          <p:nvPr/>
+        </p:nvSpPr>
+        <p:spPr>
+          <a:xfrm>
+            <a:off x="457200" y="2578608"/>
+            <a:ext cx="411480" cy="411480"/>
+          </a:xfrm>
+          <a:prstGeom prst="ellipse">
+            <a:avLst/>
+          </a:prstGeom>
+          <a:solidFill>
+            <a:srgbClr val="3E9E6B"/>
+          </a:solidFill>
+          <a:ln w="12700">
+            <a:solidFill>
+              <a:srgbClr val="3E9E6B"/>
+            </a:solidFill>
+            <a:prstDash val="solid"/>
+          </a:ln>
+        </p:spPr>
+      </p:sp>
+      <p:pic>
+        <p:nvPicPr>
+          <p:cNvPr id="11" name="Image 2" descr="preencoded.png">    </p:cNvPr>
+          <p:cNvPicPr>
+            <a:picLocks noChangeAspect="1"/>
+          </p:cNvPicPr>
+          <p:nvPr/>
+        </p:nvPicPr>
+        <p:blipFill>
+          <a:blip r:embed="rId3"/>
+          <a:stretch>
+            <a:fillRect/>
+          </a:stretch>
+        </p:blipFill>
+        <p:spPr>
+          <a:xfrm>
+            <a:off x="547726" y="2669134"/>
+            <a:ext cx="230429" cy="230429"/>
+          </a:xfrm>
+          <a:prstGeom prst="rect">
+            <a:avLst/>
+          </a:prstGeom>
+        </p:spPr>
+      </p:pic>
+      <p:sp>
+        <p:nvSpPr>
+          <p:cNvPr id="12" name="Text 7"/>
+          <p:cNvSpPr txBox="1"/>
+          <p:nvPr/>
+        </p:nvSpPr>
+        <p:spPr>
+          <a:xfrm>
+            <a:off x="1005840" y="2578608"/>
+            <a:ext cx="4023360" cy="502920"/>
+          </a:xfrm>
+          <a:prstGeom prst="rect">
+            <a:avLst/>
+          </a:prstGeom>
+          <a:noFill/>
+          <a:ln/>
+        </p:spPr>
+        <p:txBody>
+          <a:bodyPr wrap="square" lIns="0" tIns="0" rIns="0" bIns="0" rtlCol="0" anchor="ctr"/>
+          <a:lstStyle/>
+          <a:p>
+            <a:pPr indent="0" marL="0">
+              <a:buNone/>
+            </a:pPr>
+            <a:r>
+              <a:rPr lang="en-US" sz="1050" dirty="0">
+                <a:solidFill>
+                  <a:srgbClr val="1B2B30"/>
+                </a:solidFill>
+                <a:latin typeface="Meiryo" pitchFamily="34" charset="0"/>
+                <a:ea typeface="Meiryo" pitchFamily="34" charset="-122"/>
+                <a:cs typeface="Meiryo" pitchFamily="34" charset="-120"/>
+              </a:rPr>
+              <a:t>互換レイヤー、FSP 設定・ピン修正、カメラ／AI タスク化</a:t>
+            </a:r>
+            <a:endParaRPr lang="en-US" sz="1050" dirty="0"/>
+          </a:p>
+        </p:txBody>
+      </p:sp>
+      <p:sp>
+        <p:nvSpPr>
+          <p:cNvPr id="13" name="Shape 8"/>
+          <p:cNvSpPr/>
+          <p:nvPr/>
+        </p:nvSpPr>
+        <p:spPr>
+          <a:xfrm>
+            <a:off x="457200" y="3182112"/>
+            <a:ext cx="411480" cy="411480"/>
+          </a:xfrm>
+          <a:prstGeom prst="ellipse">
+            <a:avLst/>
+          </a:prstGeom>
+          <a:solidFill>
+            <a:srgbClr val="3E9E6B"/>
+          </a:solidFill>
+          <a:ln w="12700">
+            <a:solidFill>
+              <a:srgbClr val="3E9E6B"/>
+            </a:solidFill>
+            <a:prstDash val="solid"/>
+          </a:ln>
+        </p:spPr>
+      </p:sp>
+      <p:pic>
+        <p:nvPicPr>
+          <p:cNvPr id="14" name="Image 3" descr="preencoded.png">    </p:cNvPr>
+          <p:cNvPicPr>
+            <a:picLocks noChangeAspect="1"/>
+          </p:cNvPicPr>
+          <p:nvPr/>
+        </p:nvPicPr>
+        <p:blipFill>
+          <a:blip r:embed="rId4"/>
+          <a:stretch>
+            <a:fillRect/>
+          </a:stretch>
+        </p:blipFill>
+        <p:spPr>
+          <a:xfrm>
+            <a:off x="547726" y="3272638"/>
+            <a:ext cx="230429" cy="230429"/>
+          </a:xfrm>
+          <a:prstGeom prst="rect">
+            <a:avLst/>
+          </a:prstGeom>
+        </p:spPr>
+      </p:pic>
+      <p:sp>
+        <p:nvSpPr>
+          <p:cNvPr id="15" name="Text 9"/>
+          <p:cNvSpPr txBox="1"/>
+          <p:nvPr/>
+        </p:nvSpPr>
+        <p:spPr>
+          <a:xfrm>
+            <a:off x="1005840" y="3182112"/>
+            <a:ext cx="4023360" cy="502920"/>
+          </a:xfrm>
+          <a:prstGeom prst="rect">
+            <a:avLst/>
+          </a:prstGeom>
+          <a:noFill/>
+          <a:ln/>
+        </p:spPr>
+        <p:txBody>
+          <a:bodyPr wrap="square" lIns="0" tIns="0" rIns="0" bIns="0" rtlCol="0" anchor="ctr"/>
+          <a:lstStyle/>
+          <a:p>
+            <a:pPr indent="0" marL="0">
+              <a:buNone/>
+            </a:pPr>
+            <a:r>
+              <a:rPr lang="en-US" sz="1050" dirty="0">
+                <a:solidFill>
+                  <a:srgbClr val="1B2B30"/>
+                </a:solidFill>
+                <a:latin typeface="Meiryo" pitchFamily="34" charset="0"/>
+                <a:ea typeface="Meiryo" pitchFamily="34" charset="-122"/>
+                <a:cs typeface="Meiryo" pitchFamily="34" charset="-120"/>
+              </a:rPr>
+              <a:t>6タスク化・転倒判定・プライバシー UI・遅延計測（実装・ビルド確認済み）</a:t>
+            </a:r>
+            <a:endParaRPr lang="en-US" sz="1050" dirty="0"/>
+          </a:p>
+        </p:txBody>
+      </p:sp>
+      <p:sp>
+        <p:nvSpPr>
+          <p:cNvPr id="16" name="Shape 10"/>
+          <p:cNvSpPr/>
+          <p:nvPr/>
+        </p:nvSpPr>
+        <p:spPr>
+          <a:xfrm>
+            <a:off x="457200" y="3785616"/>
+            <a:ext cx="411480" cy="411480"/>
+          </a:xfrm>
+          <a:prstGeom prst="ellipse">
+            <a:avLst/>
+          </a:prstGeom>
+          <a:solidFill>
+            <a:srgbClr val="E89B2F"/>
+          </a:solidFill>
+          <a:ln w="12700">
+            <a:solidFill>
+              <a:srgbClr val="E89B2F"/>
+            </a:solidFill>
+            <a:prstDash val="solid"/>
+          </a:ln>
+        </p:spPr>
+      </p:sp>
+      <p:pic>
+        <p:nvPicPr>
+          <p:cNvPr id="17" name="Image 4" descr="preencoded.png">    </p:cNvPr>
+          <p:cNvPicPr>
+            <a:picLocks noChangeAspect="1"/>
+          </p:cNvPicPr>
+          <p:nvPr/>
+        </p:nvPicPr>
+        <p:blipFill>
+          <a:blip r:embed="rId5"/>
+          <a:stretch>
+            <a:fillRect/>
+          </a:stretch>
+        </p:blipFill>
+        <p:spPr>
+          <a:xfrm>
+            <a:off x="547726" y="3876142"/>
+            <a:ext cx="230429" cy="230429"/>
+          </a:xfrm>
+          <a:prstGeom prst="rect">
+            <a:avLst/>
+          </a:prstGeom>
+        </p:spPr>
+      </p:pic>
+      <p:sp>
+        <p:nvSpPr>
+          <p:cNvPr id="18" name="Text 11"/>
+          <p:cNvSpPr txBox="1"/>
+          <p:nvPr/>
+        </p:nvSpPr>
+        <p:spPr>
+          <a:xfrm>
+            <a:off x="1005840" y="3785616"/>
+            <a:ext cx="4023360" cy="502920"/>
+          </a:xfrm>
+          <a:prstGeom prst="rect">
+            <a:avLst/>
+          </a:prstGeom>
+          <a:noFill/>
+          <a:ln/>
+        </p:spPr>
+        <p:txBody>
+          <a:bodyPr wrap="square" lIns="0" tIns="0" rIns="0" bIns="0" rtlCol="0" anchor="ctr"/>
+          <a:lstStyle/>
+          <a:p>
+            <a:pPr indent="0" marL="0">
+              <a:buNone/>
+            </a:pPr>
+            <a:r>
+              <a:rPr lang="en-US" sz="1050" dirty="0">
+                <a:solidFill>
+                  <a:srgbClr val="1B2B30"/>
+                </a:solidFill>
+                <a:latin typeface="Meiryo" pitchFamily="34" charset="0"/>
+                <a:ea typeface="Meiryo" pitchFamily="34" charset="-122"/>
+                <a:cs typeface="Meiryo" pitchFamily="34" charset="-120"/>
+              </a:rPr>
+              <a:t>6タスク版の実機動作確認（LCD 故障のため代替機待ち）</a:t>
+            </a:r>
+            <a:endParaRPr lang="en-US" sz="1050" dirty="0"/>
+          </a:p>
+        </p:txBody>
+      </p:sp>
+      <p:sp>
+        <p:nvSpPr>
+          <p:cNvPr id="19" name="Shape 12"/>
+          <p:cNvSpPr/>
+          <p:nvPr/>
+        </p:nvSpPr>
+        <p:spPr>
+          <a:xfrm>
+            <a:off x="5212080" y="1325880"/>
+            <a:ext cx="3474720" cy="3154680"/>
+          </a:xfrm>
+          <a:prstGeom prst="roundRect">
+            <a:avLst>
+              <a:gd name="adj" fmla="val 2319"/>
+            </a:avLst>
+          </a:prstGeom>
+          <a:solidFill>
+            <a:srgbClr val="E3F0F1"/>
+          </a:solidFill>
+          <a:ln w="9525">
+            <a:solidFill>
+              <a:srgbClr val="C9D6D8"/>
+            </a:solidFill>
+            <a:prstDash val="solid"/>
+          </a:ln>
+        </p:spPr>
+      </p:sp>
+      <p:sp>
+        <p:nvSpPr>
+          <p:cNvPr id="20" name="Text 13"/>
+          <p:cNvSpPr txBox="1"/>
+          <p:nvPr/>
+        </p:nvSpPr>
+        <p:spPr>
+          <a:xfrm>
+            <a:off x="5394960" y="1463040"/>
+            <a:ext cx="3108960" cy="365760"/>
+          </a:xfrm>
+          <a:prstGeom prst="rect">
+            <a:avLst/>
+          </a:prstGeom>
+          <a:noFill/>
+          <a:ln/>
+        </p:spPr>
+        <p:txBody>
+          <a:bodyPr wrap="square" lIns="0" tIns="0" rIns="0" bIns="0" rtlCol="0" anchor="ctr"/>
+          <a:lstStyle/>
+          <a:p>
+            <a:pPr indent="0" marL="0">
+              <a:buNone/>
+            </a:pPr>
+            <a:r>
+              <a:rPr lang="en-US" sz="1400" b="1" dirty="0">
+                <a:solidFill>
+                  <a:srgbClr val="0F2A33"/>
+                </a:solidFill>
+                <a:latin typeface="Meiryo" pitchFamily="34" charset="0"/>
+                <a:ea typeface="Meiryo" pitchFamily="34" charset="-122"/>
+                <a:cs typeface="Meiryo" pitchFamily="34" charset="-120"/>
+              </a:rPr>
+              <a:t>代替機到着後の予定</a:t>
+            </a:r>
+            <a:endParaRPr lang="en-US" sz="1400" dirty="0"/>
+          </a:p>
+        </p:txBody>
+      </p:sp>
+      <p:sp>
+        <p:nvSpPr>
+          <p:cNvPr id="21" name="Shape 14"/>
+          <p:cNvSpPr/>
+          <p:nvPr/>
+        </p:nvSpPr>
+        <p:spPr>
+          <a:xfrm>
+            <a:off x="5394960" y="1965960"/>
+            <a:ext cx="329184" cy="329184"/>
+          </a:xfrm>
+          <a:prstGeom prst="ellipse">
+            <a:avLst/>
+          </a:prstGeom>
+          <a:solidFill>
+            <a:srgbClr val="1F6F78"/>
+          </a:solidFill>
+          <a:ln w="12700">
+            <a:solidFill>
+              <a:srgbClr val="1F6F78"/>
+            </a:solidFill>
+            <a:prstDash val="solid"/>
+          </a:ln>
+        </p:spPr>
+      </p:sp>
+      <p:sp>
+        <p:nvSpPr>
+          <p:cNvPr id="22" name="Text 15"/>
+          <p:cNvSpPr txBox="1"/>
+          <p:nvPr/>
+        </p:nvSpPr>
+        <p:spPr>
+          <a:xfrm>
+            <a:off x="5394960" y="1965960"/>
+            <a:ext cx="329184" cy="329184"/>
+          </a:xfrm>
+          <a:prstGeom prst="rect">
+            <a:avLst/>
+          </a:prstGeom>
+          <a:noFill/>
+          <a:ln/>
+        </p:spPr>
+        <p:txBody>
+          <a:bodyPr wrap="square" lIns="0" tIns="0" rIns="0" bIns="0" rtlCol="0" anchor="ctr"/>
+          <a:lstStyle/>
+          <a:p>
+            <a:pPr algn="ctr" indent="0" marL="0">
+              <a:buNone/>
+            </a:pPr>
+            <a:r>
+              <a:rPr lang="en-US" sz="1100" b="1" dirty="0">
+                <a:solidFill>
+                  <a:srgbClr val="FFFFFF"/>
+                </a:solidFill>
+                <a:latin typeface="Arial" pitchFamily="34" charset="0"/>
+                <a:ea typeface="Arial" pitchFamily="34" charset="-122"/>
+                <a:cs typeface="Arial" pitchFamily="34" charset="-120"/>
+              </a:rPr>
+              <a:t>1</a:t>
+            </a:r>
+            <a:endParaRPr lang="en-US" sz="1100" dirty="0"/>
+          </a:p>
+        </p:txBody>
+      </p:sp>
+      <p:sp>
+        <p:nvSpPr>
+          <p:cNvPr id="23" name="Text 16"/>
+          <p:cNvSpPr txBox="1"/>
+          <p:nvPr/>
+        </p:nvSpPr>
+        <p:spPr>
+          <a:xfrm>
+            <a:off x="5852160" y="1920240"/>
+            <a:ext cx="2743200" cy="420624"/>
+          </a:xfrm>
+          <a:prstGeom prst="rect">
+            <a:avLst/>
+          </a:prstGeom>
+          <a:noFill/>
+          <a:ln/>
+        </p:spPr>
+        <p:txBody>
+          <a:bodyPr wrap="square" lIns="0" tIns="0" rIns="0" bIns="0" rtlCol="0" anchor="ctr"/>
+          <a:lstStyle/>
+          <a:p>
+            <a:pPr indent="0" marL="0">
+              <a:buNone/>
+            </a:pPr>
+            <a:r>
+              <a:rPr lang="en-US" sz="1100" dirty="0">
+                <a:solidFill>
+                  <a:srgbClr val="1B2B30"/>
+                </a:solidFill>
+                <a:latin typeface="Meiryo" pitchFamily="34" charset="0"/>
+                <a:ea typeface="Meiryo" pitchFamily="34" charset="-122"/>
+                <a:cs typeface="Meiryo" pitchFamily="34" charset="-120"/>
+              </a:rPr>
+              <a:t>6タスク版の実機動作確認</a:t>
+            </a:r>
+            <a:endParaRPr lang="en-US" sz="1100" dirty="0"/>
+          </a:p>
+        </p:txBody>
+      </p:sp>
+      <p:sp>
+        <p:nvSpPr>
+          <p:cNvPr id="24" name="Shape 17"/>
+          <p:cNvSpPr/>
+          <p:nvPr/>
+        </p:nvSpPr>
+        <p:spPr>
+          <a:xfrm>
+            <a:off x="5394960" y="2468880"/>
+            <a:ext cx="329184" cy="329184"/>
+          </a:xfrm>
+          <a:prstGeom prst="ellipse">
+            <a:avLst/>
+          </a:prstGeom>
+          <a:solidFill>
+            <a:srgbClr val="1F6F78"/>
+          </a:solidFill>
+          <a:ln w="12700">
+            <a:solidFill>
+              <a:srgbClr val="1F6F78"/>
+            </a:solidFill>
+            <a:prstDash val="solid"/>
+          </a:ln>
+        </p:spPr>
+      </p:sp>
+      <p:sp>
+        <p:nvSpPr>
+          <p:cNvPr id="25" name="Text 18"/>
+          <p:cNvSpPr txBox="1"/>
+          <p:nvPr/>
+        </p:nvSpPr>
+        <p:spPr>
+          <a:xfrm>
+            <a:off x="5394960" y="2468880"/>
+            <a:ext cx="329184" cy="329184"/>
+          </a:xfrm>
+          <a:prstGeom prst="rect">
+            <a:avLst/>
+          </a:prstGeom>
+          <a:noFill/>
+          <a:ln/>
+        </p:spPr>
+        <p:txBody>
+          <a:bodyPr wrap="square" lIns="0" tIns="0" rIns="0" bIns="0" rtlCol="0" anchor="ctr"/>
+          <a:lstStyle/>
+          <a:p>
+            <a:pPr algn="ctr" indent="0" marL="0">
+              <a:buNone/>
+            </a:pPr>
+            <a:r>
+              <a:rPr lang="en-US" sz="1100" b="1" dirty="0">
+                <a:solidFill>
+                  <a:srgbClr val="FFFFFF"/>
+                </a:solidFill>
+                <a:latin typeface="Arial" pitchFamily="34" charset="0"/>
+                <a:ea typeface="Arial" pitchFamily="34" charset="-122"/>
+                <a:cs typeface="Arial" pitchFamily="34" charset="-120"/>
+              </a:rPr>
+              <a:t>2</a:t>
+            </a:r>
+            <a:endParaRPr lang="en-US" sz="1100" dirty="0"/>
+          </a:p>
+        </p:txBody>
+      </p:sp>
+      <p:sp>
+        <p:nvSpPr>
+          <p:cNvPr id="26" name="Text 19"/>
+          <p:cNvSpPr txBox="1"/>
+          <p:nvPr/>
+        </p:nvSpPr>
+        <p:spPr>
+          <a:xfrm>
+            <a:off x="5852160" y="2423160"/>
+            <a:ext cx="2743200" cy="420624"/>
+          </a:xfrm>
+          <a:prstGeom prst="rect">
+            <a:avLst/>
+          </a:prstGeom>
+          <a:noFill/>
+          <a:ln/>
+        </p:spPr>
+        <p:txBody>
+          <a:bodyPr wrap="square" lIns="0" tIns="0" rIns="0" bIns="0" rtlCol="0" anchor="ctr"/>
+          <a:lstStyle/>
+          <a:p>
+            <a:pPr indent="0" marL="0">
+              <a:buNone/>
+            </a:pPr>
+            <a:r>
+              <a:rPr lang="en-US" sz="1100" dirty="0">
+                <a:solidFill>
+                  <a:srgbClr val="1B2B30"/>
+                </a:solidFill>
+                <a:latin typeface="Meiryo" pitchFamily="34" charset="0"/>
+                <a:ea typeface="Meiryo" pitchFamily="34" charset="-122"/>
+                <a:cs typeface="Meiryo" pitchFamily="34" charset="-120"/>
+              </a:rPr>
+              <a:t>判定しきい値の実機調整</a:t>
+            </a:r>
+            <a:endParaRPr lang="en-US" sz="1100" dirty="0"/>
+          </a:p>
+        </p:txBody>
+      </p:sp>
+      <p:sp>
+        <p:nvSpPr>
+          <p:cNvPr id="27" name="Shape 20"/>
+          <p:cNvSpPr/>
+          <p:nvPr/>
+        </p:nvSpPr>
+        <p:spPr>
+          <a:xfrm>
+            <a:off x="5394960" y="2971800"/>
+            <a:ext cx="329184" cy="329184"/>
+          </a:xfrm>
+          <a:prstGeom prst="ellipse">
+            <a:avLst/>
+          </a:prstGeom>
+          <a:solidFill>
+            <a:srgbClr val="1F6F78"/>
+          </a:solidFill>
+          <a:ln w="12700">
+            <a:solidFill>
+              <a:srgbClr val="1F6F78"/>
+            </a:solidFill>
+            <a:prstDash val="solid"/>
+          </a:ln>
+        </p:spPr>
+      </p:sp>
+      <p:sp>
+        <p:nvSpPr>
+          <p:cNvPr id="28" name="Text 21"/>
+          <p:cNvSpPr txBox="1"/>
+          <p:nvPr/>
+        </p:nvSpPr>
+        <p:spPr>
+          <a:xfrm>
+            <a:off x="5394960" y="2971800"/>
+            <a:ext cx="329184" cy="329184"/>
+          </a:xfrm>
+          <a:prstGeom prst="rect">
+            <a:avLst/>
+          </a:prstGeom>
+          <a:noFill/>
+          <a:ln/>
+        </p:spPr>
+        <p:txBody>
+          <a:bodyPr wrap="square" lIns="0" tIns="0" rIns="0" bIns="0" rtlCol="0" anchor="ctr"/>
+          <a:lstStyle/>
+          <a:p>
+            <a:pPr algn="ctr" indent="0" marL="0">
+              <a:buNone/>
+            </a:pPr>
+            <a:r>
+              <a:rPr lang="en-US" sz="1100" b="1" dirty="0">
+                <a:solidFill>
+                  <a:srgbClr val="FFFFFF"/>
+                </a:solidFill>
+                <a:latin typeface="Arial" pitchFamily="34" charset="0"/>
+                <a:ea typeface="Arial" pitchFamily="34" charset="-122"/>
+                <a:cs typeface="Arial" pitchFamily="34" charset="-120"/>
+              </a:rPr>
+              <a:t>3</a:t>
+            </a:r>
+            <a:endParaRPr lang="en-US" sz="1100" dirty="0"/>
+          </a:p>
+        </p:txBody>
+      </p:sp>
+      <p:sp>
+        <p:nvSpPr>
+          <p:cNvPr id="29" name="Text 22"/>
+          <p:cNvSpPr txBox="1"/>
+          <p:nvPr/>
+        </p:nvSpPr>
+        <p:spPr>
+          <a:xfrm>
+            <a:off x="5852160" y="2926080"/>
+            <a:ext cx="2743200" cy="420624"/>
+          </a:xfrm>
+          <a:prstGeom prst="rect">
+            <a:avLst/>
+          </a:prstGeom>
+          <a:noFill/>
+          <a:ln/>
+        </p:spPr>
+        <p:txBody>
+          <a:bodyPr wrap="square" lIns="0" tIns="0" rIns="0" bIns="0" rtlCol="0" anchor="ctr"/>
+          <a:lstStyle/>
+          <a:p>
+            <a:pPr indent="0" marL="0">
+              <a:buNone/>
+            </a:pPr>
+            <a:r>
+              <a:rPr lang="en-US" sz="1100" dirty="0">
+                <a:solidFill>
+                  <a:srgbClr val="1B2B30"/>
+                </a:solidFill>
+                <a:latin typeface="Meiryo" pitchFamily="34" charset="0"/>
+                <a:ea typeface="Meiryo" pitchFamily="34" charset="-122"/>
+                <a:cs typeface="Meiryo" pitchFamily="34" charset="-120"/>
+              </a:rPr>
+              <a:t>検知率・誤報率の評価</a:t>
+            </a:r>
+            <a:endParaRPr lang="en-US" sz="1100" dirty="0"/>
+          </a:p>
+        </p:txBody>
+      </p:sp>
+      <p:sp>
+        <p:nvSpPr>
+          <p:cNvPr id="30" name="Shape 23"/>
+          <p:cNvSpPr/>
+          <p:nvPr/>
+        </p:nvSpPr>
+        <p:spPr>
+          <a:xfrm>
+            <a:off x="5394960" y="3474720"/>
+            <a:ext cx="329184" cy="329184"/>
+          </a:xfrm>
+          <a:prstGeom prst="ellipse">
+            <a:avLst/>
+          </a:prstGeom>
+          <a:solidFill>
+            <a:srgbClr val="1F6F78"/>
+          </a:solidFill>
+          <a:ln w="12700">
+            <a:solidFill>
+              <a:srgbClr val="1F6F78"/>
+            </a:solidFill>
+            <a:prstDash val="solid"/>
+          </a:ln>
+        </p:spPr>
+      </p:sp>
+      <p:sp>
+        <p:nvSpPr>
+          <p:cNvPr id="31" name="Text 24"/>
+          <p:cNvSpPr txBox="1"/>
+          <p:nvPr/>
+        </p:nvSpPr>
+        <p:spPr>
+          <a:xfrm>
+            <a:off x="5394960" y="3474720"/>
+            <a:ext cx="329184" cy="329184"/>
+          </a:xfrm>
+          <a:prstGeom prst="rect">
+            <a:avLst/>
+          </a:prstGeom>
+          <a:noFill/>
+          <a:ln/>
+        </p:spPr>
+        <p:txBody>
+          <a:bodyPr wrap="square" lIns="0" tIns="0" rIns="0" bIns="0" rtlCol="0" anchor="ctr"/>
+          <a:lstStyle/>
+          <a:p>
+            <a:pPr algn="ctr" indent="0" marL="0">
+              <a:buNone/>
+            </a:pPr>
+            <a:r>
+              <a:rPr lang="en-US" sz="1100" b="1" dirty="0">
+                <a:solidFill>
+                  <a:srgbClr val="FFFFFF"/>
+                </a:solidFill>
+                <a:latin typeface="Arial" pitchFamily="34" charset="0"/>
+                <a:ea typeface="Arial" pitchFamily="34" charset="-122"/>
+                <a:cs typeface="Arial" pitchFamily="34" charset="-120"/>
+              </a:rPr>
+              <a:t>4</a:t>
+            </a:r>
+            <a:endParaRPr lang="en-US" sz="1100" dirty="0"/>
+          </a:p>
+        </p:txBody>
+      </p:sp>
+      <p:sp>
+        <p:nvSpPr>
+          <p:cNvPr id="32" name="Text 25"/>
+          <p:cNvSpPr txBox="1"/>
+          <p:nvPr/>
+        </p:nvSpPr>
+        <p:spPr>
+          <a:xfrm>
+            <a:off x="5852160" y="3429000"/>
+            <a:ext cx="2743200" cy="420624"/>
+          </a:xfrm>
+          <a:prstGeom prst="rect">
+            <a:avLst/>
+          </a:prstGeom>
+          <a:noFill/>
+          <a:ln/>
+        </p:spPr>
+        <p:txBody>
+          <a:bodyPr wrap="square" lIns="0" tIns="0" rIns="0" bIns="0" rtlCol="0" anchor="ctr"/>
+          <a:lstStyle/>
+          <a:p>
+            <a:pPr indent="0" marL="0">
+              <a:buNone/>
+            </a:pPr>
+            <a:r>
+              <a:rPr lang="en-US" sz="1100" dirty="0">
+                <a:solidFill>
+                  <a:srgbClr val="1B2B30"/>
+                </a:solidFill>
+                <a:latin typeface="Meiryo" pitchFamily="34" charset="0"/>
+                <a:ea typeface="Meiryo" pitchFamily="34" charset="-122"/>
+                <a:cs typeface="Meiryo" pitchFamily="34" charset="-120"/>
+              </a:rPr>
+              <a:t>遅延の計測・デモ動画撮影</a:t>
+            </a:r>
+            <a:endParaRPr lang="en-US" sz="1100" dirty="0"/>
+          </a:p>
+        </p:txBody>
+      </p:sp>
+      <p:sp>
+        <p:nvSpPr>
+          <p:cNvPr id="33" name="Shape 26"/>
+          <p:cNvSpPr/>
+          <p:nvPr/>
+        </p:nvSpPr>
+        <p:spPr>
+          <a:xfrm>
+            <a:off x="5394960" y="3977640"/>
+            <a:ext cx="329184" cy="329184"/>
+          </a:xfrm>
+          <a:prstGeom prst="ellipse">
+            <a:avLst/>
+          </a:prstGeom>
+          <a:solidFill>
+            <a:srgbClr val="1F6F78"/>
+          </a:solidFill>
+          <a:ln w="12700">
+            <a:solidFill>
+              <a:srgbClr val="1F6F78"/>
+            </a:solidFill>
+            <a:prstDash val="solid"/>
+          </a:ln>
+        </p:spPr>
+      </p:sp>
+      <p:sp>
+        <p:nvSpPr>
+          <p:cNvPr id="34" name="Text 27"/>
+          <p:cNvSpPr txBox="1"/>
+          <p:nvPr/>
+        </p:nvSpPr>
+        <p:spPr>
+          <a:xfrm>
+            <a:off x="5394960" y="3977640"/>
+            <a:ext cx="329184" cy="329184"/>
+          </a:xfrm>
+          <a:prstGeom prst="rect">
+            <a:avLst/>
+          </a:prstGeom>
+          <a:noFill/>
+          <a:ln/>
+        </p:spPr>
+        <p:txBody>
+          <a:bodyPr wrap="square" lIns="0" tIns="0" rIns="0" bIns="0" rtlCol="0" anchor="ctr"/>
+          <a:lstStyle/>
+          <a:p>
+            <a:pPr algn="ctr" indent="0" marL="0">
+              <a:buNone/>
+            </a:pPr>
+            <a:r>
+              <a:rPr lang="en-US" sz="1100" b="1" dirty="0">
+                <a:solidFill>
+                  <a:srgbClr val="FFFFFF"/>
+                </a:solidFill>
+                <a:latin typeface="Arial" pitchFamily="34" charset="0"/>
+                <a:ea typeface="Arial" pitchFamily="34" charset="-122"/>
+                <a:cs typeface="Arial" pitchFamily="34" charset="-120"/>
+              </a:rPr>
+              <a:t>5</a:t>
+            </a:r>
+            <a:endParaRPr lang="en-US" sz="1100" dirty="0"/>
+          </a:p>
+        </p:txBody>
+      </p:sp>
+      <p:sp>
+        <p:nvSpPr>
+          <p:cNvPr id="35" name="Text 28"/>
+          <p:cNvSpPr txBox="1"/>
+          <p:nvPr/>
+        </p:nvSpPr>
+        <p:spPr>
+          <a:xfrm>
+            <a:off x="5852160" y="3931920"/>
+            <a:ext cx="2743200" cy="420624"/>
+          </a:xfrm>
+          <a:prstGeom prst="rect">
+            <a:avLst/>
+          </a:prstGeom>
+          <a:noFill/>
+          <a:ln/>
+        </p:spPr>
+        <p:txBody>
+          <a:bodyPr wrap="square" lIns="0" tIns="0" rIns="0" bIns="0" rtlCol="0" anchor="ctr"/>
+          <a:lstStyle/>
+          <a:p>
+            <a:pPr indent="0" marL="0">
+              <a:buNone/>
+            </a:pPr>
+            <a:r>
+              <a:rPr lang="en-US" sz="1100" dirty="0">
+                <a:solidFill>
+                  <a:srgbClr val="1B2B30"/>
+                </a:solidFill>
+                <a:latin typeface="Meiryo" pitchFamily="34" charset="0"/>
+                <a:ea typeface="Meiryo" pitchFamily="34" charset="-122"/>
+                <a:cs typeface="Meiryo" pitchFamily="34" charset="-120"/>
+              </a:rPr>
+              <a:t>人物検出モデルへの置き換え</a:t>
+            </a:r>
+            <a:endParaRPr lang="en-US" sz="1100" dirty="0"/>
+          </a:p>
+        </p:txBody>
+      </p:sp>
+      <p:sp>
+        <p:nvSpPr>
+          <p:cNvPr id="36" name="Text 29"/>
+          <p:cNvSpPr txBox="1"/>
+          <p:nvPr/>
+        </p:nvSpPr>
+        <p:spPr>
+          <a:xfrm>
+            <a:off x="8412480" y="4800600"/>
+            <a:ext cx="365760" cy="228600"/>
+          </a:xfrm>
+          <a:prstGeom prst="rect">
+            <a:avLst/>
+          </a:prstGeom>
+          <a:noFill/>
+          <a:ln/>
+        </p:spPr>
+        <p:txBody>
+          <a:bodyPr wrap="square" lIns="0" tIns="0" rIns="0" bIns="0" rtlCol="0" anchor="ctr"/>
+          <a:lstStyle/>
+          <a:p>
+            <a:pPr algn="r" indent="0" marL="0">
+              <a:buNone/>
+            </a:pPr>
+            <a:r>
+              <a:rPr lang="en-US" sz="900" dirty="0">
+                <a:solidFill>
+                  <a:srgbClr val="5B6B70"/>
+                </a:solidFill>
+                <a:latin typeface="Meiryo" pitchFamily="34" charset="0"/>
+                <a:ea typeface="Meiryo" pitchFamily="34" charset="-122"/>
+                <a:cs typeface="Meiryo" pitchFamily="34" charset="-120"/>
+              </a:rPr>
+              <a:t>12</a:t>
+            </a:r>
+            <a:endParaRPr lang="en-US" sz="900" dirty="0"/>
+          </a:p>
+        </p:txBody>
+      </p:sp>
+    </p:spTree>
+  </p:cSld>
+  <p:clrMapOvr>
+    <a:masterClrMapping/>
+  </p:clrMapOvr>
+</p:sld>
+</file>
+
+<file path=ppt/slides/slide13.xml><?xml version="1.0" encoding="utf-8"?>
+<p:sld xmlns:a="http://schemas.openxmlformats.org/drawingml/2006/main" xmlns:r="http://schemas.openxmlformats.org/officeDocument/2006/relationships" xmlns:p="http://schemas.openxmlformats.org/presentationml/2006/main">
+  <p:cSld name="Slide 13">
+    <p:bg>
+      <p:bgPr>
+        <a:solidFill>
+          <a:srgbClr val="FFFFFF"/>
+        </a:solidFill>
+      </p:bgPr>
+    </p:bg>
+    <p:spTree>
+      <p:nvGrpSpPr>
+        <p:cNvPr id="1" name=""/>
+        <p:cNvGrpSpPr/>
+        <p:nvPr/>
+      </p:nvGrpSpPr>
+      <p:grpSpPr>
+        <a:xfrm>
+          <a:off x="0" y="0"/>
+          <a:ext cx="0" cy="0"/>
+          <a:chOff x="0" y="0"/>
+          <a:chExt cx="0" cy="0"/>
+        </a:xfrm>
+      </p:grpSpPr>
+      <p:sp>
+        <p:nvSpPr>
+          <p:cNvPr id="2" name="Text 0"/>
+          <p:cNvSpPr txBox="1"/>
+          <p:nvPr/>
+        </p:nvSpPr>
+        <p:spPr>
+          <a:xfrm>
+            <a:off x="457200" y="274320"/>
+            <a:ext cx="8229600" cy="548640"/>
+          </a:xfrm>
+          <a:prstGeom prst="rect">
+            <a:avLst/>
+          </a:prstGeom>
+          <a:noFill/>
+          <a:ln/>
+        </p:spPr>
+        <p:txBody>
+          <a:bodyPr wrap="square" lIns="0" tIns="0" rIns="0" bIns="0" rtlCol="0" anchor="ctr"/>
+          <a:lstStyle/>
+          <a:p>
+            <a:pPr indent="0" marL="0">
+              <a:buNone/>
+            </a:pPr>
+            <a:r>
+              <a:rPr lang="en-US" sz="2400" b="1" dirty="0">
+                <a:solidFill>
+                  <a:srgbClr val="0F2A33"/>
+                </a:solidFill>
+                <a:latin typeface="Meiryo" pitchFamily="34" charset="0"/>
+                <a:ea typeface="Meiryo" pitchFamily="34" charset="-122"/>
+                <a:cs typeface="Meiryo" pitchFamily="34" charset="-120"/>
+              </a:rPr>
               <a:t>計画書からの変更点</a:t>
             </a:r>
             <a:endParaRPr lang="en-US" sz="2400" dirty="0"/>
@@ -4784,7 +6480,7 @@
       </p:sp>
       <p:graphicFrame>
         <p:nvGraphicFramePr>
-          <p:cNvPr id="13" name="Table 0"/>
+          <p:cNvPr id="14" name="Table 0"/>
           <p:cNvGraphicFramePr>
             <a:graphicFrameLocks noGrp="1"/>
           </p:cNvGraphicFramePr>
@@ -6280,7 +7976,7 @@
                           <a:ea typeface="Meiryo" pitchFamily="34" charset="-122"/>
                           <a:cs typeface="Meiryo" pitchFamily="34" charset="-120"/>
                         </a:rPr>
-                        <a:t>6タスク（現在は2タスクで移植）</a:t>
+                        <a:t>6タスク</a:t>
                       </a:r>
                       <a:endParaRPr lang="en-US" sz="1050" dirty="0">
                         <a:latin typeface="Meiryo" charset="0"/>
@@ -6345,7 +8041,7 @@
                           <a:ea typeface="Meiryo" pitchFamily="34" charset="-122"/>
                           <a:cs typeface="Meiryo" pitchFamily="34" charset="-120"/>
                         </a:rPr>
-                        <a:t>まず公式サンプルの確実な移植を優先</a:t>
+                        <a:t>計画どおり（公式サンプルの 2 スレッドを内包）</a:t>
                       </a:r>
                       <a:endParaRPr lang="en-US" sz="1050" dirty="0">
                         <a:latin typeface="Meiryo" charset="0"/>
@@ -6431,7 +8127,7 @@
                 <a:ea typeface="Meiryo" pitchFamily="34" charset="-122"/>
                 <a:cs typeface="Meiryo" pitchFamily="34" charset="-120"/>
               </a:rPr>
-              <a:t>12</a:t>
+              <a:t>13</a:t>
             </a:r>
             <a:endParaRPr lang="en-US" sz="900" dirty="0"/>
           </a:p>
@@ -6445,9 +8141,9 @@
 </p:sld>
 </file>
 
-<file path=ppt/slides/slide13.xml><?xml version="1.0" encoding="utf-8"?>
+<file path=ppt/slides/slide14.xml><?xml version="1.0" encoding="utf-8"?>
 <p:sld xmlns:a="http://schemas.openxmlformats.org/drawingml/2006/main" xmlns:r="http://schemas.openxmlformats.org/officeDocument/2006/relationships" xmlns:p="http://schemas.openxmlformats.org/presentationml/2006/main">
-  <p:cSld name="Slide 13">
+  <p:cSld name="Slide 14">
     <p:bg>
       <p:bgPr>
         <a:solidFill>
@@ -6766,7 +8462,7 @@
                 <a:ea typeface="Meiryo" pitchFamily="34" charset="-122"/>
                 <a:cs typeface="Meiryo" pitchFamily="34" charset="-120"/>
               </a:rPr>
-              <a:t>代替機到着後、6タスク化・転倒判定・定量評価を行い更新版を提出</a:t>
+              <a:t>6タスク・転倒判定を実装済み。代替機で実機評価を行い更新版を提出</a:t>
             </a:r>
             <a:endParaRPr lang="en-US" sz="1500" dirty="0"/>
           </a:p>
@@ -8890,7 +10586,7 @@
                 <a:ea typeface="Meiryo" pitchFamily="34" charset="-122"/>
                 <a:cs typeface="Meiryo" pitchFamily="34" charset="-120"/>
               </a:rPr>
-              <a:t>μT-Kernel 上のタスク構成（現在の実装）</a:t>
+              <a:t>ルネサス AI サンプルのタスク化</a:t>
             </a:r>
             <a:endParaRPr lang="en-US" sz="2400" dirty="0"/>
           </a:p>
@@ -8929,7 +10625,7 @@
                 <a:ea typeface="Meiryo" pitchFamily="34" charset="-122"/>
                 <a:cs typeface="Meiryo" pitchFamily="34" charset="-120"/>
               </a:rPr>
-              <a:t>ルネサス公式の FreeRTOS 版サンプル（2スレッド）を、ロジックを変えずに μT-Kernel のタスクとして動かす</a:t>
+              <a:t>公式の FreeRTOS 版サンプル（2スレッド）を、ロジックを変えずに μT-Kernel のタスクとして動かす</a:t>
             </a:r>
             <a:endParaRPr lang="en-US" sz="1200" dirty="0"/>
           </a:p>
@@ -9034,7 +10730,7 @@
                 <a:ea typeface="Meiryo" pitchFamily="34" charset="-122"/>
                 <a:cs typeface="Meiryo" pitchFamily="34" charset="-120"/>
               </a:rPr>
-              <a:t>優先度 9 ／ スタック 8KB</a:t>
+              <a:t>優先度 10 ／ スタック 8KB</a:t>
             </a:r>
             <a:endParaRPr lang="en-US" sz="1000" dirty="0"/>
           </a:p>
@@ -9245,7 +10941,7 @@
                 <a:ea typeface="Meiryo" pitchFamily="34" charset="-122"/>
                 <a:cs typeface="Meiryo" pitchFamily="34" charset="-120"/>
               </a:rPr>
-              <a:t>優先度 10 ／ スタック 32KB</a:t>
+              <a:t>優先度 12 ／ スタック 32KB</a:t>
             </a:r>
             <a:endParaRPr lang="en-US" sz="1000" dirty="0"/>
           </a:p>
@@ -11384,7 +13080,7 @@
                 <a:ea typeface="Meiryo" pitchFamily="34" charset="-122"/>
                 <a:cs typeface="Meiryo" pitchFamily="34" charset="-120"/>
               </a:rPr>
-              <a:t>最終構成：6タスクで役割を分ける（設計済み）</a:t>
+              <a:t>6タスクで役割を分ける（実装済み）</a:t>
             </a:r>
             <a:endParaRPr lang="en-US" sz="2400" dirty="0"/>
           </a:p>
@@ -11730,7 +13426,7 @@
                 <a:ea typeface="Meiryo" pitchFamily="34" charset="-122"/>
                 <a:cs typeface="Meiryo" pitchFamily="34" charset="-120"/>
               </a:rPr>
-              <a:t>周期ハンドラで各タスクの生存・スタック残量を確認</a:t>
+              <a:t>周期ハンドラで毎秒起床し、各タスクのハートビートを監視</a:t>
             </a:r>
             <a:endParaRPr lang="en-US" sz="1100" dirty="0"/>
           </a:p>
@@ -11895,7 +13591,7 @@
                 <a:ea typeface="Meiryo" pitchFamily="34" charset="-122"/>
                 <a:cs typeface="Meiryo" pitchFamily="34" charset="-120"/>
               </a:rPr>
-              <a:t>フレーム完了割り込み → バッファ切替・前処理</a:t>
+              <a:t>フレーム取得・前処理、取得時刻を記録（遅延計測用）</a:t>
             </a:r>
             <a:endParaRPr lang="en-US" sz="1100" dirty="0"/>
           </a:p>
@@ -12060,7 +13756,7 @@
                 <a:ea typeface="Meiryo" pitchFamily="34" charset="-122"/>
                 <a:cs typeface="Meiryo" pitchFamily="34" charset="-120"/>
               </a:rPr>
-              <a:t>検出枠の時系列から状態を判定</a:t>
+              <a:t>検出枠の時系列から状態を判定（fall_judge.c）</a:t>
             </a:r>
             <a:endParaRPr lang="en-US" sz="1100" dirty="0"/>
           </a:p>
@@ -12429,7 +14125,7 @@
                 <a:ea typeface="Meiryo" pitchFamily="34" charset="-122"/>
                 <a:cs typeface="Meiryo" pitchFamily="34" charset="-120"/>
               </a:rPr>
-              <a:t>同期：割り込み→イベントフラグ、推論→判定はメッセージバッファ、判定→アラートはイベントフラグ</a:t>
+              <a:t>同期：割り込み→イベントフラグ、推論→判定はメッセージバッファ、判定→アラートはイベントフラグ、ログは優先度継承ミューテックス</a:t>
             </a:r>
             <a:endParaRPr lang="en-US" sz="950" dirty="0"/>
           </a:p>
@@ -12539,7 +14235,7 @@
                 <a:ea typeface="Meiryo" pitchFamily="34" charset="-122"/>
                 <a:cs typeface="Meiryo" pitchFamily="34" charset="-120"/>
               </a:rPr>
-              <a:t>転倒判定：検出枠の「形」と「時間」で判断</a:t>
+              <a:t>転倒判定：検出枠の「動き」と「時間」で判断</a:t>
             </a:r>
             <a:endParaRPr lang="en-US" sz="2400" dirty="0"/>
           </a:p>
@@ -12578,7 +14274,7 @@
                 <a:ea typeface="Meiryo" pitchFamily="34" charset="-122"/>
                 <a:cs typeface="Meiryo" pitchFamily="34" charset="-120"/>
               </a:rPr>
-              <a:t>物体検出の結果を状態遷移で判定する（設計済み・代替機到着後に実装）</a:t>
+              <a:t>実装済み（Application/fall_judge.c）。顔検出モデルの枠の中心位置を状態遷移で判定</a:t>
             </a:r>
             <a:endParaRPr lang="en-US" sz="1200" dirty="0"/>
           </a:p>
@@ -12808,8 +14504,8 @@
         </p:nvSpPr>
         <p:spPr>
           <a:xfrm>
-            <a:off x="1920240" y="1325880"/>
-            <a:ext cx="1097280" cy="685800"/>
+            <a:off x="1783080" y="1325880"/>
+            <a:ext cx="1371600" cy="685800"/>
           </a:xfrm>
           <a:prstGeom prst="rect">
             <a:avLst/>
@@ -12833,7 +14529,7 @@
                 <a:ea typeface="Meiryo" pitchFamily="34" charset="-122"/>
                 <a:cs typeface="Meiryo" pitchFamily="34" charset="-120"/>
               </a:rPr>
-              <a:t>横長に変化</a:t>
+              <a:t>1秒で20%以上下降</a:t>
             </a:r>
             <a:endParaRPr lang="en-US" sz="900" dirty="0"/>
           </a:p>
@@ -12850,7 +14546,7 @@
                 <a:ea typeface="Meiryo" pitchFamily="34" charset="-122"/>
                 <a:cs typeface="Meiryo" pitchFamily="34" charset="-120"/>
               </a:rPr>
-              <a:t>h/w &lt; 0.8</a:t>
+              <a:t>＋下4割に入る</a:t>
             </a:r>
             <a:endParaRPr lang="en-US" sz="900" dirty="0"/>
           </a:p>
@@ -12888,8 +14584,8 @@
         </p:nvSpPr>
         <p:spPr>
           <a:xfrm>
-            <a:off x="1920240" y="2606040"/>
-            <a:ext cx="1097280" cy="548640"/>
+            <a:off x="1783080" y="2606040"/>
+            <a:ext cx="1371600" cy="365760"/>
           </a:xfrm>
           <a:prstGeom prst="rect">
             <a:avLst/>
@@ -12913,24 +14609,7 @@
                 <a:ea typeface="Meiryo" pitchFamily="34" charset="-122"/>
                 <a:cs typeface="Meiryo" pitchFamily="34" charset="-120"/>
               </a:rPr>
-              <a:t>縦長に戻る</a:t>
-            </a:r>
-            <a:endParaRPr lang="en-US" sz="900" dirty="0"/>
-          </a:p>
-          <a:p>
-            <a:pPr algn="ctr" indent="0" marL="0">
-              <a:buNone/>
-            </a:pPr>
-            <a:r>
-              <a:rPr lang="en-US" sz="900" dirty="0">
-                <a:solidFill>
-                  <a:srgbClr val="1B2B30"/>
-                </a:solidFill>
-                <a:latin typeface="Meiryo" pitchFamily="34" charset="0"/>
-                <a:ea typeface="Meiryo" pitchFamily="34" charset="-122"/>
-                <a:cs typeface="Meiryo" pitchFamily="34" charset="-120"/>
-              </a:rPr>
-              <a:t>h/w ≥ 1.2</a:t>
+              <a:t>上の領域に戻る</a:t>
             </a:r>
             <a:endParaRPr lang="en-US" sz="900" dirty="0"/>
           </a:p>
@@ -12968,8 +14647,8 @@
         </p:nvSpPr>
         <p:spPr>
           <a:xfrm>
-            <a:off x="4389120" y="1463040"/>
-            <a:ext cx="1097280" cy="685800"/>
+            <a:off x="4297680" y="1463040"/>
+            <a:ext cx="1280160" cy="685800"/>
           </a:xfrm>
           <a:prstGeom prst="rect">
             <a:avLst/>
@@ -12993,7 +14672,7 @@
                 <a:ea typeface="Meiryo" pitchFamily="34" charset="-122"/>
                 <a:cs typeface="Meiryo" pitchFamily="34" charset="-120"/>
               </a:rPr>
-              <a:t>横長が</a:t>
+              <a:t>3秒継続</a:t>
             </a:r>
             <a:endParaRPr lang="en-US" sz="900" dirty="0"/>
           </a:p>
@@ -13010,7 +14689,7 @@
                 <a:ea typeface="Meiryo" pitchFamily="34" charset="-122"/>
                 <a:cs typeface="Meiryo" pitchFamily="34" charset="-120"/>
               </a:rPr>
-              <a:t>3秒以上継続</a:t>
+              <a:t>（見えなくても）</a:t>
             </a:r>
             <a:endParaRPr lang="en-US" sz="900" dirty="0"/>
           </a:p>
@@ -13119,7 +14798,7 @@
                 <a:ea typeface="Meiryo" pitchFamily="34" charset="-122"/>
                 <a:cs typeface="Meiryo" pitchFamily="34" charset="-120"/>
               </a:rPr>
-              <a:t>起き上がる（h/w ≥ 1.2）</a:t>
+              <a:t>上の領域に1秒以上（起き上がり）</a:t>
             </a:r>
             <a:endParaRPr lang="en-US" sz="900" dirty="0"/>
           </a:p>
@@ -13282,7 +14961,7 @@
                 <a:ea typeface="Meiryo" pitchFamily="34" charset="-122"/>
                 <a:cs typeface="Meiryo" pitchFamily="34" charset="-120"/>
               </a:rPr>
-              <a:t>姿勢推定モデルより変換・後処理のリスクが小さく、短期間で確実に動かせる。「しゃがむ・座る」の誤報は継続時間の条件で抑え、しきい値は実機評価で調整する。</a:t>
+              <a:t>姿勢推定より変換・後処理のリスクが小さい。ゆっくり座る動作は下降速度の条件で、しゃがんで立つ動作は継続時間の条件で除外。人物検出モデルでは枠の縦横比も使える（設定で切替）。</a:t>
             </a:r>
             <a:endParaRPr lang="en-US" sz="1050" dirty="0"/>
           </a:p>
@@ -13431,7 +15110,7 @@
                 <a:ea typeface="Meiryo" pitchFamily="34" charset="-122"/>
                 <a:cs typeface="Meiryo" pitchFamily="34" charset="-120"/>
               </a:rPr>
-              <a:t>LCD 表示のイメージ（設計）</a:t>
+              <a:t>UI タスク（優先度 14）が 200ms ごとに描画（実装済み・実機確認待ち）</a:t>
             </a:r>
             <a:endParaRPr lang="en-US" sz="1200" dirty="0"/>
           </a:p>

</xml_diff>